<commit_message>
Add 5-stream revenue projection with conservative scenario
</commit_message>
<xml_diff>
--- a/Lakshyam_Investor_Pitch.pptx
+++ b/Lakshyam_Investor_Pitch.pptx
@@ -12026,8 +12026,8 @@
         </p:nvSpPr>
         <p:spPr>
           <a:xfrm>
-            <a:off x="731520" y="365760"/>
-            <a:ext cx="5486400" cy="365760"/>
+            <a:off x="731520" y="274320"/>
+            <a:ext cx="5486400" cy="274320"/>
           </a:xfrm>
           <a:prstGeom prst="rect">
             <a:avLst/>
@@ -12041,7 +12041,7 @@
           <a:lstStyle/>
           <a:p>
             <a:pPr algn="l">
-              <a:defRPr sz="1400" b="1">
+              <a:defRPr sz="1200" b="1">
                 <a:solidFill>
                   <a:srgbClr val="A78BFA"/>
                 </a:solidFill>
@@ -12062,8 +12062,8 @@
         </p:nvSpPr>
         <p:spPr>
           <a:xfrm>
-            <a:off x="731520" y="822960"/>
-            <a:ext cx="9144000" cy="548640"/>
+            <a:off x="731520" y="548640"/>
+            <a:ext cx="9144000" cy="365760"/>
           </a:xfrm>
           <a:prstGeom prst="rect">
             <a:avLst/>
@@ -12077,7 +12077,7 @@
           <a:lstStyle/>
           <a:p>
             <a:pPr algn="l">
-              <a:defRPr sz="3600" b="1">
+              <a:defRPr sz="2800" b="1">
                 <a:solidFill>
                   <a:srgbClr val="FFFFFF"/>
                 </a:solidFill>
@@ -12098,8 +12098,8 @@
         </p:nvSpPr>
         <p:spPr>
           <a:xfrm>
-            <a:off x="1371600" y="1645920"/>
-            <a:ext cx="4389120" cy="2743200"/>
+            <a:off x="731520" y="1005840"/>
+            <a:ext cx="3474720" cy="1645920"/>
           </a:xfrm>
           <a:prstGeom prst="roundRect">
             <a:avLst/>
@@ -12143,8 +12143,8 @@
         </p:nvSpPr>
         <p:spPr>
           <a:xfrm>
-            <a:off x="1554480" y="1783080"/>
-            <a:ext cx="4023360" cy="365760"/>
+            <a:off x="914400" y="1143000"/>
+            <a:ext cx="3108960" cy="365760"/>
           </a:xfrm>
           <a:prstGeom prst="rect">
             <a:avLst/>
@@ -12179,8 +12179,8 @@
         </p:nvSpPr>
         <p:spPr>
           <a:xfrm>
-            <a:off x="1554480" y="2103120"/>
-            <a:ext cx="4023360" cy="2148840"/>
+            <a:off x="914400" y="1463040"/>
+            <a:ext cx="3108960" cy="1051560"/>
           </a:xfrm>
           <a:prstGeom prst="rect">
             <a:avLst/>
@@ -12202,15 +12202,7 @@
               </a:defRPr>
             </a:pPr>
             <a:r>
-              <a:t>AI-generated questions</a:t>
-            </a:r>
-            <a:br/>
-            <a:r>
-              <a:t>Basic analytics</a:t>
-            </a:r>
-            <a:br/>
-            <a:r>
-              <a:t>Daily current affairs</a:t>
+              <a:t>AI-generated questions, basic analytics, daily current affairs</a:t>
             </a:r>
           </a:p>
         </p:txBody>
@@ -12223,8 +12215,8 @@
         </p:nvSpPr>
         <p:spPr>
           <a:xfrm>
-            <a:off x="1371600" y="4389120"/>
-            <a:ext cx="4389120" cy="548640"/>
+            <a:off x="731520" y="2286000"/>
+            <a:ext cx="3474720" cy="365760"/>
           </a:xfrm>
           <a:prstGeom prst="rect">
             <a:avLst/>
@@ -12238,7 +12230,7 @@
           <a:lstStyle/>
           <a:p>
             <a:pPr algn="ctr">
-              <a:defRPr sz="2800" b="1">
+              <a:defRPr sz="2000" b="1">
                 <a:solidFill>
                   <a:srgbClr val="34D399"/>
                 </a:solidFill>
@@ -12259,8 +12251,8 @@
         </p:nvSpPr>
         <p:spPr>
           <a:xfrm>
-            <a:off x="6400800" y="1645920"/>
-            <a:ext cx="4389120" cy="2743200"/>
+            <a:off x="4389120" y="1005840"/>
+            <a:ext cx="3474720" cy="1645920"/>
           </a:xfrm>
           <a:prstGeom prst="roundRect">
             <a:avLst/>
@@ -12304,8 +12296,8 @@
         </p:nvSpPr>
         <p:spPr>
           <a:xfrm>
-            <a:off x="6583680" y="1783080"/>
-            <a:ext cx="4023360" cy="365760"/>
+            <a:off x="4572000" y="1143000"/>
+            <a:ext cx="3108960" cy="365760"/>
           </a:xfrm>
           <a:prstGeom prst="rect">
             <a:avLst/>
@@ -12340,8 +12332,8 @@
         </p:nvSpPr>
         <p:spPr>
           <a:xfrm>
-            <a:off x="6583680" y="2103120"/>
-            <a:ext cx="4023360" cy="2148840"/>
+            <a:off x="4572000" y="1463040"/>
+            <a:ext cx="3108960" cy="1051560"/>
           </a:xfrm>
           <a:prstGeom prst="rect">
             <a:avLst/>
@@ -12363,23 +12355,7 @@
               </a:defRPr>
             </a:pPr>
             <a:r>
-              <a:t>Unlimited questions</a:t>
-            </a:r>
-            <a:br/>
-            <a:r>
-              <a:t>Offline question bank</a:t>
-            </a:r>
-            <a:br/>
-            <a:r>
-              <a:t>Priority AI generation</a:t>
-            </a:r>
-            <a:br/>
-            <a:r>
-              <a:t>Detailed analytics</a:t>
-            </a:r>
-            <a:br/>
-            <a:r>
-              <a:t>Ad-free</a:t>
+              <a:t>Unlimited questions, offline question bank, priority AI, detailed analytics, ad-free</a:t>
             </a:r>
           </a:p>
         </p:txBody>
@@ -12392,8 +12368,8 @@
         </p:nvSpPr>
         <p:spPr>
           <a:xfrm>
-            <a:off x="6400800" y="4389120"/>
-            <a:ext cx="4389120" cy="548640"/>
+            <a:off x="4389120" y="2286000"/>
+            <a:ext cx="3474720" cy="365760"/>
           </a:xfrm>
           <a:prstGeom prst="rect">
             <a:avLst/>
@@ -12407,7 +12383,7 @@
           <a:lstStyle/>
           <a:p>
             <a:pPr algn="ctr">
-              <a:defRPr sz="2800" b="1">
+              <a:defRPr sz="2000" b="1">
                 <a:solidFill>
                   <a:srgbClr val="FBBF24"/>
                 </a:solidFill>
@@ -12428,8 +12404,8 @@
         </p:nvSpPr>
         <p:spPr>
           <a:xfrm>
-            <a:off x="731520" y="5029200"/>
-            <a:ext cx="10789920" cy="1371600"/>
+            <a:off x="8046720" y="1005840"/>
+            <a:ext cx="3474720" cy="1645920"/>
           </a:xfrm>
           <a:prstGeom prst="roundRect">
             <a:avLst/>
@@ -12473,8 +12449,8 @@
         </p:nvSpPr>
         <p:spPr>
           <a:xfrm>
-            <a:off x="914400" y="5166360"/>
-            <a:ext cx="10424160" cy="365760"/>
+            <a:off x="8229600" y="1143000"/>
+            <a:ext cx="3108960" cy="365760"/>
           </a:xfrm>
           <a:prstGeom prst="rect">
             <a:avLst/>
@@ -12509,8 +12485,8 @@
         </p:nvSpPr>
         <p:spPr>
           <a:xfrm>
-            <a:off x="914400" y="5486400"/>
-            <a:ext cx="10424160" cy="777240"/>
+            <a:off x="8229600" y="1463040"/>
+            <a:ext cx="3108960" cy="1051560"/>
           </a:xfrm>
           <a:prstGeom prst="rect">
             <a:avLst/>
@@ -12542,8 +12518,8 @@
         </p:nvSpPr>
         <p:spPr>
           <a:xfrm>
-            <a:off x="1005840" y="5394960"/>
-            <a:ext cx="10332720" cy="1097280"/>
+            <a:off x="8229600" y="1280160"/>
+            <a:ext cx="3108960" cy="1188720"/>
           </a:xfrm>
           <a:prstGeom prst="rect">
             <a:avLst/>
@@ -12560,7 +12536,7 @@
               <a:spcBef>
                 <a:spcPts val="400"/>
               </a:spcBef>
-              <a:defRPr sz="1100">
+              <a:defRPr sz="1000">
                 <a:solidFill>
                   <a:srgbClr val="CCCCCC"/>
                 </a:solidFill>
@@ -12568,7 +12544,7 @@
               </a:defRPr>
             </a:pPr>
             <a:r>
-              <a:t>▸  AI inference cost per question: ~Rs.0.001 (free tier Groq+Gemini -&gt; Rs.0)</a:t>
+              <a:t>▸  AI cost: ~Rs.0.001/question</a:t>
             </a:r>
           </a:p>
           <a:p>
@@ -12576,7 +12552,7 @@
               <a:spcBef>
                 <a:spcPts val="400"/>
               </a:spcBef>
-              <a:defRPr sz="1100">
+              <a:defRPr sz="1000">
                 <a:solidFill>
                   <a:srgbClr val="CCCCCC"/>
                 </a:solidFill>
@@ -12584,7 +12560,7 @@
               </a:defRPr>
             </a:pPr>
             <a:r>
-              <a:t>▸  Premium at Rs.199/mo with 300 questions/user = Rs.0.30 AI cost -&gt; 99.85% gross margin</a:t>
+              <a:t>▸  Premium: 99.85% gross margin</a:t>
             </a:r>
           </a:p>
           <a:p>
@@ -12592,7 +12568,7 @@
               <a:spcBef>
                 <a:spcPts val="400"/>
               </a:spcBef>
-              <a:defRPr sz="1100">
+              <a:defRPr sz="1000">
                 <a:solidFill>
                   <a:srgbClr val="CCCCCC"/>
                 </a:solidFill>
@@ -12600,15 +12576,266 @@
               </a:defRPr>
             </a:pPr>
             <a:r>
-              <a:t>▸  Even with GPT-4o-mini upgrade: Rs.5/user/mo -&gt; 97.5% margin</a:t>
-            </a:r>
-          </a:p>
-          <a:p>
-            <a:pPr>
-              <a:spcBef>
-                <a:spcPts val="400"/>
-              </a:spcBef>
-              <a:defRPr sz="1100">
+              <a:t>▸  GPT-4o-mini: 97.5% margin</a:t>
+            </a:r>
+          </a:p>
+        </p:txBody>
+      </p:sp>
+      <p:sp>
+        <p:nvSpPr>
+          <p:cNvPr id="16" name="Rectangle 15"/>
+          <p:cNvSpPr/>
+          <p:nvPr/>
+        </p:nvSpPr>
+        <p:spPr>
+          <a:xfrm>
+            <a:off x="731520" y="2834640"/>
+            <a:ext cx="2560320" cy="237744"/>
+          </a:xfrm>
+          <a:prstGeom prst="rect">
+            <a:avLst/>
+          </a:prstGeom>
+          <a:solidFill>
+            <a:srgbClr val="A78BFA"/>
+          </a:solidFill>
+          <a:ln>
+            <a:noFill/>
+          </a:ln>
+        </p:spPr>
+        <p:style>
+          <a:lnRef idx="1">
+            <a:schemeClr val="accent1"/>
+          </a:lnRef>
+          <a:fillRef idx="3">
+            <a:schemeClr val="accent1"/>
+          </a:fillRef>
+          <a:effectRef idx="2">
+            <a:schemeClr val="accent1"/>
+          </a:effectRef>
+          <a:fontRef idx="minor">
+            <a:schemeClr val="lt1"/>
+          </a:fontRef>
+        </p:style>
+        <p:txBody>
+          <a:bodyPr rtlCol="0" anchor="ctr"/>
+          <a:lstStyle/>
+          <a:p>
+            <a:pPr algn="ctr">
+              <a:defRPr sz="700" b="1">
+                <a:solidFill>
+                  <a:srgbClr val="FFFFFF"/>
+                </a:solidFill>
+                <a:latin typeface="Calibri"/>
+              </a:defRPr>
+            </a:pPr>
+            <a:r>
+              <a:t>Metric</a:t>
+            </a:r>
+          </a:p>
+        </p:txBody>
+      </p:sp>
+      <p:sp>
+        <p:nvSpPr>
+          <p:cNvPr id="17" name="Rectangle 16"/>
+          <p:cNvSpPr/>
+          <p:nvPr/>
+        </p:nvSpPr>
+        <p:spPr>
+          <a:xfrm>
+            <a:off x="3291840" y="2834640"/>
+            <a:ext cx="1828800" cy="237744"/>
+          </a:xfrm>
+          <a:prstGeom prst="rect">
+            <a:avLst/>
+          </a:prstGeom>
+          <a:solidFill>
+            <a:srgbClr val="A78BFA"/>
+          </a:solidFill>
+          <a:ln>
+            <a:noFill/>
+          </a:ln>
+        </p:spPr>
+        <p:style>
+          <a:lnRef idx="1">
+            <a:schemeClr val="accent1"/>
+          </a:lnRef>
+          <a:fillRef idx="3">
+            <a:schemeClr val="accent1"/>
+          </a:fillRef>
+          <a:effectRef idx="2">
+            <a:schemeClr val="accent1"/>
+          </a:effectRef>
+          <a:fontRef idx="minor">
+            <a:schemeClr val="lt1"/>
+          </a:fontRef>
+        </p:style>
+        <p:txBody>
+          <a:bodyPr rtlCol="0" anchor="ctr"/>
+          <a:lstStyle/>
+          <a:p>
+            <a:pPr algn="ctr">
+              <a:defRPr sz="700" b="1">
+                <a:solidFill>
+                  <a:srgbClr val="FFFFFF"/>
+                </a:solidFill>
+                <a:latin typeface="Calibri"/>
+              </a:defRPr>
+            </a:pPr>
+            <a:r>
+              <a:t>Year 1</a:t>
+            </a:r>
+          </a:p>
+        </p:txBody>
+      </p:sp>
+      <p:sp>
+        <p:nvSpPr>
+          <p:cNvPr id="18" name="Rectangle 17"/>
+          <p:cNvSpPr/>
+          <p:nvPr/>
+        </p:nvSpPr>
+        <p:spPr>
+          <a:xfrm>
+            <a:off x="5120640" y="2834640"/>
+            <a:ext cx="1828800" cy="237744"/>
+          </a:xfrm>
+          <a:prstGeom prst="rect">
+            <a:avLst/>
+          </a:prstGeom>
+          <a:solidFill>
+            <a:srgbClr val="A78BFA"/>
+          </a:solidFill>
+          <a:ln>
+            <a:noFill/>
+          </a:ln>
+        </p:spPr>
+        <p:style>
+          <a:lnRef idx="1">
+            <a:schemeClr val="accent1"/>
+          </a:lnRef>
+          <a:fillRef idx="3">
+            <a:schemeClr val="accent1"/>
+          </a:fillRef>
+          <a:effectRef idx="2">
+            <a:schemeClr val="accent1"/>
+          </a:effectRef>
+          <a:fontRef idx="minor">
+            <a:schemeClr val="lt1"/>
+          </a:fontRef>
+        </p:style>
+        <p:txBody>
+          <a:bodyPr rtlCol="0" anchor="ctr"/>
+          <a:lstStyle/>
+          <a:p>
+            <a:pPr algn="ctr">
+              <a:defRPr sz="700" b="1">
+                <a:solidFill>
+                  <a:srgbClr val="FFFFFF"/>
+                </a:solidFill>
+                <a:latin typeface="Calibri"/>
+              </a:defRPr>
+            </a:pPr>
+            <a:r>
+              <a:t>Year 2</a:t>
+            </a:r>
+          </a:p>
+        </p:txBody>
+      </p:sp>
+      <p:sp>
+        <p:nvSpPr>
+          <p:cNvPr id="19" name="Rectangle 18"/>
+          <p:cNvSpPr/>
+          <p:nvPr/>
+        </p:nvSpPr>
+        <p:spPr>
+          <a:xfrm>
+            <a:off x="6949440" y="2834640"/>
+            <a:ext cx="1828800" cy="237744"/>
+          </a:xfrm>
+          <a:prstGeom prst="rect">
+            <a:avLst/>
+          </a:prstGeom>
+          <a:solidFill>
+            <a:srgbClr val="A78BFA"/>
+          </a:solidFill>
+          <a:ln>
+            <a:noFill/>
+          </a:ln>
+        </p:spPr>
+        <p:style>
+          <a:lnRef idx="1">
+            <a:schemeClr val="accent1"/>
+          </a:lnRef>
+          <a:fillRef idx="3">
+            <a:schemeClr val="accent1"/>
+          </a:fillRef>
+          <a:effectRef idx="2">
+            <a:schemeClr val="accent1"/>
+          </a:effectRef>
+          <a:fontRef idx="minor">
+            <a:schemeClr val="lt1"/>
+          </a:fontRef>
+        </p:style>
+        <p:txBody>
+          <a:bodyPr rtlCol="0" anchor="ctr"/>
+          <a:lstStyle/>
+          <a:p>
+            <a:pPr algn="ctr">
+              <a:defRPr sz="700" b="1">
+                <a:solidFill>
+                  <a:srgbClr val="FFFFFF"/>
+                </a:solidFill>
+                <a:latin typeface="Calibri"/>
+              </a:defRPr>
+            </a:pPr>
+            <a:r>
+              <a:t>Year 3</a:t>
+            </a:r>
+          </a:p>
+        </p:txBody>
+      </p:sp>
+      <p:sp>
+        <p:nvSpPr>
+          <p:cNvPr id="20" name="Rectangle 19"/>
+          <p:cNvSpPr/>
+          <p:nvPr/>
+        </p:nvSpPr>
+        <p:spPr>
+          <a:xfrm>
+            <a:off x="731520" y="3072384"/>
+            <a:ext cx="2560320" cy="237744"/>
+          </a:xfrm>
+          <a:prstGeom prst="rect">
+            <a:avLst/>
+          </a:prstGeom>
+          <a:solidFill>
+            <a:srgbClr val="1A1A2E"/>
+          </a:solidFill>
+          <a:ln w="12700">
+            <a:solidFill>
+              <a:srgbClr val="2A2A3E"/>
+            </a:solidFill>
+          </a:ln>
+        </p:spPr>
+        <p:style>
+          <a:lnRef idx="1">
+            <a:schemeClr val="accent1"/>
+          </a:lnRef>
+          <a:fillRef idx="3">
+            <a:schemeClr val="accent1"/>
+          </a:fillRef>
+          <a:effectRef idx="2">
+            <a:schemeClr val="accent1"/>
+          </a:effectRef>
+          <a:fontRef idx="minor">
+            <a:schemeClr val="lt1"/>
+          </a:fontRef>
+        </p:style>
+        <p:txBody>
+          <a:bodyPr rtlCol="0" anchor="ctr"/>
+          <a:lstStyle/>
+          <a:p>
+            <a:pPr algn="ctr">
+              <a:defRPr sz="700" b="0">
                 <a:solidFill>
                   <a:srgbClr val="CCCCCC"/>
                 </a:solidFill>
@@ -12616,14 +12843,4288 @@
               </a:defRPr>
             </a:pPr>
             <a:r>
-              <a:t>▸  Coaching centers charge Rs.15,000-50,000/year per student</a:t>
-            </a:r>
-          </a:p>
-        </p:txBody>
-      </p:sp>
-      <p:sp>
-        <p:nvSpPr>
-          <p:cNvPr id="16" name="TextBox 15"/>
+              <a:t>Free Users</a:t>
+            </a:r>
+          </a:p>
+        </p:txBody>
+      </p:sp>
+      <p:sp>
+        <p:nvSpPr>
+          <p:cNvPr id="21" name="Rectangle 20"/>
+          <p:cNvSpPr/>
+          <p:nvPr/>
+        </p:nvSpPr>
+        <p:spPr>
+          <a:xfrm>
+            <a:off x="3291840" y="3072384"/>
+            <a:ext cx="1828800" cy="237744"/>
+          </a:xfrm>
+          <a:prstGeom prst="rect">
+            <a:avLst/>
+          </a:prstGeom>
+          <a:solidFill>
+            <a:srgbClr val="1A1A2E"/>
+          </a:solidFill>
+          <a:ln w="12700">
+            <a:solidFill>
+              <a:srgbClr val="2A2A3E"/>
+            </a:solidFill>
+          </a:ln>
+        </p:spPr>
+        <p:style>
+          <a:lnRef idx="1">
+            <a:schemeClr val="accent1"/>
+          </a:lnRef>
+          <a:fillRef idx="3">
+            <a:schemeClr val="accent1"/>
+          </a:fillRef>
+          <a:effectRef idx="2">
+            <a:schemeClr val="accent1"/>
+          </a:effectRef>
+          <a:fontRef idx="minor">
+            <a:schemeClr val="lt1"/>
+          </a:fontRef>
+        </p:style>
+        <p:txBody>
+          <a:bodyPr rtlCol="0" anchor="ctr"/>
+          <a:lstStyle/>
+          <a:p>
+            <a:pPr algn="ctr">
+              <a:defRPr sz="700" b="0">
+                <a:solidFill>
+                  <a:srgbClr val="CCCCCC"/>
+                </a:solidFill>
+                <a:latin typeface="Calibri"/>
+              </a:defRPr>
+            </a:pPr>
+            <a:r>
+              <a:t>10,000</a:t>
+            </a:r>
+          </a:p>
+        </p:txBody>
+      </p:sp>
+      <p:sp>
+        <p:nvSpPr>
+          <p:cNvPr id="22" name="Rectangle 21"/>
+          <p:cNvSpPr/>
+          <p:nvPr/>
+        </p:nvSpPr>
+        <p:spPr>
+          <a:xfrm>
+            <a:off x="5120640" y="3072384"/>
+            <a:ext cx="1828800" cy="237744"/>
+          </a:xfrm>
+          <a:prstGeom prst="rect">
+            <a:avLst/>
+          </a:prstGeom>
+          <a:solidFill>
+            <a:srgbClr val="1A1A2E"/>
+          </a:solidFill>
+          <a:ln w="12700">
+            <a:solidFill>
+              <a:srgbClr val="2A2A3E"/>
+            </a:solidFill>
+          </a:ln>
+        </p:spPr>
+        <p:style>
+          <a:lnRef idx="1">
+            <a:schemeClr val="accent1"/>
+          </a:lnRef>
+          <a:fillRef idx="3">
+            <a:schemeClr val="accent1"/>
+          </a:fillRef>
+          <a:effectRef idx="2">
+            <a:schemeClr val="accent1"/>
+          </a:effectRef>
+          <a:fontRef idx="minor">
+            <a:schemeClr val="lt1"/>
+          </a:fontRef>
+        </p:style>
+        <p:txBody>
+          <a:bodyPr rtlCol="0" anchor="ctr"/>
+          <a:lstStyle/>
+          <a:p>
+            <a:pPr algn="ctr">
+              <a:defRPr sz="700" b="0">
+                <a:solidFill>
+                  <a:srgbClr val="CCCCCC"/>
+                </a:solidFill>
+                <a:latin typeface="Calibri"/>
+              </a:defRPr>
+            </a:pPr>
+            <a:r>
+              <a:t>50,000</a:t>
+            </a:r>
+          </a:p>
+        </p:txBody>
+      </p:sp>
+      <p:sp>
+        <p:nvSpPr>
+          <p:cNvPr id="23" name="Rectangle 22"/>
+          <p:cNvSpPr/>
+          <p:nvPr/>
+        </p:nvSpPr>
+        <p:spPr>
+          <a:xfrm>
+            <a:off x="6949440" y="3072384"/>
+            <a:ext cx="1828800" cy="237744"/>
+          </a:xfrm>
+          <a:prstGeom prst="rect">
+            <a:avLst/>
+          </a:prstGeom>
+          <a:solidFill>
+            <a:srgbClr val="1A1A2E"/>
+          </a:solidFill>
+          <a:ln w="12700">
+            <a:solidFill>
+              <a:srgbClr val="2A2A3E"/>
+            </a:solidFill>
+          </a:ln>
+        </p:spPr>
+        <p:style>
+          <a:lnRef idx="1">
+            <a:schemeClr val="accent1"/>
+          </a:lnRef>
+          <a:fillRef idx="3">
+            <a:schemeClr val="accent1"/>
+          </a:fillRef>
+          <a:effectRef idx="2">
+            <a:schemeClr val="accent1"/>
+          </a:effectRef>
+          <a:fontRef idx="minor">
+            <a:schemeClr val="lt1"/>
+          </a:fontRef>
+        </p:style>
+        <p:txBody>
+          <a:bodyPr rtlCol="0" anchor="ctr"/>
+          <a:lstStyle/>
+          <a:p>
+            <a:pPr algn="ctr">
+              <a:defRPr sz="700" b="0">
+                <a:solidFill>
+                  <a:srgbClr val="CCCCCC"/>
+                </a:solidFill>
+                <a:latin typeface="Calibri"/>
+              </a:defRPr>
+            </a:pPr>
+            <a:r>
+              <a:t>200,000</a:t>
+            </a:r>
+          </a:p>
+        </p:txBody>
+      </p:sp>
+      <p:sp>
+        <p:nvSpPr>
+          <p:cNvPr id="24" name="Rectangle 23"/>
+          <p:cNvSpPr/>
+          <p:nvPr/>
+        </p:nvSpPr>
+        <p:spPr>
+          <a:xfrm>
+            <a:off x="731520" y="3310128"/>
+            <a:ext cx="2560320" cy="237744"/>
+          </a:xfrm>
+          <a:prstGeom prst="rect">
+            <a:avLst/>
+          </a:prstGeom>
+          <a:solidFill>
+            <a:srgbClr val="151528"/>
+          </a:solidFill>
+          <a:ln w="12700">
+            <a:solidFill>
+              <a:srgbClr val="2A2A3E"/>
+            </a:solidFill>
+          </a:ln>
+        </p:spPr>
+        <p:style>
+          <a:lnRef idx="1">
+            <a:schemeClr val="accent1"/>
+          </a:lnRef>
+          <a:fillRef idx="3">
+            <a:schemeClr val="accent1"/>
+          </a:fillRef>
+          <a:effectRef idx="2">
+            <a:schemeClr val="accent1"/>
+          </a:effectRef>
+          <a:fontRef idx="minor">
+            <a:schemeClr val="lt1"/>
+          </a:fontRef>
+        </p:style>
+        <p:txBody>
+          <a:bodyPr rtlCol="0" anchor="ctr"/>
+          <a:lstStyle/>
+          <a:p>
+            <a:pPr algn="ctr">
+              <a:defRPr sz="700" b="0">
+                <a:solidFill>
+                  <a:srgbClr val="CCCCCC"/>
+                </a:solidFill>
+                <a:latin typeface="Calibri"/>
+              </a:defRPr>
+            </a:pPr>
+            <a:r>
+              <a:t>Paid Conversion</a:t>
+            </a:r>
+          </a:p>
+        </p:txBody>
+      </p:sp>
+      <p:sp>
+        <p:nvSpPr>
+          <p:cNvPr id="25" name="Rectangle 24"/>
+          <p:cNvSpPr/>
+          <p:nvPr/>
+        </p:nvSpPr>
+        <p:spPr>
+          <a:xfrm>
+            <a:off x="3291840" y="3310128"/>
+            <a:ext cx="1828800" cy="237744"/>
+          </a:xfrm>
+          <a:prstGeom prst="rect">
+            <a:avLst/>
+          </a:prstGeom>
+          <a:solidFill>
+            <a:srgbClr val="151528"/>
+          </a:solidFill>
+          <a:ln w="12700">
+            <a:solidFill>
+              <a:srgbClr val="2A2A3E"/>
+            </a:solidFill>
+          </a:ln>
+        </p:spPr>
+        <p:style>
+          <a:lnRef idx="1">
+            <a:schemeClr val="accent1"/>
+          </a:lnRef>
+          <a:fillRef idx="3">
+            <a:schemeClr val="accent1"/>
+          </a:fillRef>
+          <a:effectRef idx="2">
+            <a:schemeClr val="accent1"/>
+          </a:effectRef>
+          <a:fontRef idx="minor">
+            <a:schemeClr val="lt1"/>
+          </a:fontRef>
+        </p:style>
+        <p:txBody>
+          <a:bodyPr rtlCol="0" anchor="ctr"/>
+          <a:lstStyle/>
+          <a:p>
+            <a:pPr algn="ctr">
+              <a:defRPr sz="700" b="0">
+                <a:solidFill>
+                  <a:srgbClr val="CCCCCC"/>
+                </a:solidFill>
+                <a:latin typeface="Calibri"/>
+              </a:defRPr>
+            </a:pPr>
+            <a:r>
+              <a:t>5%</a:t>
+            </a:r>
+          </a:p>
+        </p:txBody>
+      </p:sp>
+      <p:sp>
+        <p:nvSpPr>
+          <p:cNvPr id="26" name="Rectangle 25"/>
+          <p:cNvSpPr/>
+          <p:nvPr/>
+        </p:nvSpPr>
+        <p:spPr>
+          <a:xfrm>
+            <a:off x="5120640" y="3310128"/>
+            <a:ext cx="1828800" cy="237744"/>
+          </a:xfrm>
+          <a:prstGeom prst="rect">
+            <a:avLst/>
+          </a:prstGeom>
+          <a:solidFill>
+            <a:srgbClr val="151528"/>
+          </a:solidFill>
+          <a:ln w="12700">
+            <a:solidFill>
+              <a:srgbClr val="2A2A3E"/>
+            </a:solidFill>
+          </a:ln>
+        </p:spPr>
+        <p:style>
+          <a:lnRef idx="1">
+            <a:schemeClr val="accent1"/>
+          </a:lnRef>
+          <a:fillRef idx="3">
+            <a:schemeClr val="accent1"/>
+          </a:fillRef>
+          <a:effectRef idx="2">
+            <a:schemeClr val="accent1"/>
+          </a:effectRef>
+          <a:fontRef idx="minor">
+            <a:schemeClr val="lt1"/>
+          </a:fontRef>
+        </p:style>
+        <p:txBody>
+          <a:bodyPr rtlCol="0" anchor="ctr"/>
+          <a:lstStyle/>
+          <a:p>
+            <a:pPr algn="ctr">
+              <a:defRPr sz="700" b="0">
+                <a:solidFill>
+                  <a:srgbClr val="CCCCCC"/>
+                </a:solidFill>
+                <a:latin typeface="Calibri"/>
+              </a:defRPr>
+            </a:pPr>
+            <a:r>
+              <a:t>5%</a:t>
+            </a:r>
+          </a:p>
+        </p:txBody>
+      </p:sp>
+      <p:sp>
+        <p:nvSpPr>
+          <p:cNvPr id="27" name="Rectangle 26"/>
+          <p:cNvSpPr/>
+          <p:nvPr/>
+        </p:nvSpPr>
+        <p:spPr>
+          <a:xfrm>
+            <a:off x="6949440" y="3310128"/>
+            <a:ext cx="1828800" cy="237744"/>
+          </a:xfrm>
+          <a:prstGeom prst="rect">
+            <a:avLst/>
+          </a:prstGeom>
+          <a:solidFill>
+            <a:srgbClr val="151528"/>
+          </a:solidFill>
+          <a:ln w="12700">
+            <a:solidFill>
+              <a:srgbClr val="2A2A3E"/>
+            </a:solidFill>
+          </a:ln>
+        </p:spPr>
+        <p:style>
+          <a:lnRef idx="1">
+            <a:schemeClr val="accent1"/>
+          </a:lnRef>
+          <a:fillRef idx="3">
+            <a:schemeClr val="accent1"/>
+          </a:fillRef>
+          <a:effectRef idx="2">
+            <a:schemeClr val="accent1"/>
+          </a:effectRef>
+          <a:fontRef idx="minor">
+            <a:schemeClr val="lt1"/>
+          </a:fontRef>
+        </p:style>
+        <p:txBody>
+          <a:bodyPr rtlCol="0" anchor="ctr"/>
+          <a:lstStyle/>
+          <a:p>
+            <a:pPr algn="ctr">
+              <a:defRPr sz="700" b="0">
+                <a:solidFill>
+                  <a:srgbClr val="CCCCCC"/>
+                </a:solidFill>
+                <a:latin typeface="Calibri"/>
+              </a:defRPr>
+            </a:pPr>
+            <a:r>
+              <a:t>8%</a:t>
+            </a:r>
+          </a:p>
+        </p:txBody>
+      </p:sp>
+      <p:sp>
+        <p:nvSpPr>
+          <p:cNvPr id="28" name="Rectangle 27"/>
+          <p:cNvSpPr/>
+          <p:nvPr/>
+        </p:nvSpPr>
+        <p:spPr>
+          <a:xfrm>
+            <a:off x="731520" y="3547872"/>
+            <a:ext cx="2560320" cy="237744"/>
+          </a:xfrm>
+          <a:prstGeom prst="rect">
+            <a:avLst/>
+          </a:prstGeom>
+          <a:solidFill>
+            <a:srgbClr val="1A1A2E"/>
+          </a:solidFill>
+          <a:ln w="12700">
+            <a:solidFill>
+              <a:srgbClr val="2A2A3E"/>
+            </a:solidFill>
+          </a:ln>
+        </p:spPr>
+        <p:style>
+          <a:lnRef idx="1">
+            <a:schemeClr val="accent1"/>
+          </a:lnRef>
+          <a:fillRef idx="3">
+            <a:schemeClr val="accent1"/>
+          </a:fillRef>
+          <a:effectRef idx="2">
+            <a:schemeClr val="accent1"/>
+          </a:effectRef>
+          <a:fontRef idx="minor">
+            <a:schemeClr val="lt1"/>
+          </a:fontRef>
+        </p:style>
+        <p:txBody>
+          <a:bodyPr rtlCol="0" anchor="ctr"/>
+          <a:lstStyle/>
+          <a:p>
+            <a:pPr algn="ctr">
+              <a:defRPr sz="700" b="0">
+                <a:solidFill>
+                  <a:srgbClr val="CCCCCC"/>
+                </a:solidFill>
+                <a:latin typeface="Calibri"/>
+              </a:defRPr>
+            </a:pPr>
+            <a:r>
+              <a:t>Paying Users</a:t>
+            </a:r>
+          </a:p>
+        </p:txBody>
+      </p:sp>
+      <p:sp>
+        <p:nvSpPr>
+          <p:cNvPr id="29" name="Rectangle 28"/>
+          <p:cNvSpPr/>
+          <p:nvPr/>
+        </p:nvSpPr>
+        <p:spPr>
+          <a:xfrm>
+            <a:off x="3291840" y="3547872"/>
+            <a:ext cx="1828800" cy="237744"/>
+          </a:xfrm>
+          <a:prstGeom prst="rect">
+            <a:avLst/>
+          </a:prstGeom>
+          <a:solidFill>
+            <a:srgbClr val="1A1A2E"/>
+          </a:solidFill>
+          <a:ln w="12700">
+            <a:solidFill>
+              <a:srgbClr val="2A2A3E"/>
+            </a:solidFill>
+          </a:ln>
+        </p:spPr>
+        <p:style>
+          <a:lnRef idx="1">
+            <a:schemeClr val="accent1"/>
+          </a:lnRef>
+          <a:fillRef idx="3">
+            <a:schemeClr val="accent1"/>
+          </a:fillRef>
+          <a:effectRef idx="2">
+            <a:schemeClr val="accent1"/>
+          </a:effectRef>
+          <a:fontRef idx="minor">
+            <a:schemeClr val="lt1"/>
+          </a:fontRef>
+        </p:style>
+        <p:txBody>
+          <a:bodyPr rtlCol="0" anchor="ctr"/>
+          <a:lstStyle/>
+          <a:p>
+            <a:pPr algn="ctr">
+              <a:defRPr sz="700" b="0">
+                <a:solidFill>
+                  <a:srgbClr val="CCCCCC"/>
+                </a:solidFill>
+                <a:latin typeface="Calibri"/>
+              </a:defRPr>
+            </a:pPr>
+            <a:r>
+              <a:t>500</a:t>
+            </a:r>
+          </a:p>
+        </p:txBody>
+      </p:sp>
+      <p:sp>
+        <p:nvSpPr>
+          <p:cNvPr id="30" name="Rectangle 29"/>
+          <p:cNvSpPr/>
+          <p:nvPr/>
+        </p:nvSpPr>
+        <p:spPr>
+          <a:xfrm>
+            <a:off x="5120640" y="3547872"/>
+            <a:ext cx="1828800" cy="237744"/>
+          </a:xfrm>
+          <a:prstGeom prst="rect">
+            <a:avLst/>
+          </a:prstGeom>
+          <a:solidFill>
+            <a:srgbClr val="1A1A2E"/>
+          </a:solidFill>
+          <a:ln w="12700">
+            <a:solidFill>
+              <a:srgbClr val="2A2A3E"/>
+            </a:solidFill>
+          </a:ln>
+        </p:spPr>
+        <p:style>
+          <a:lnRef idx="1">
+            <a:schemeClr val="accent1"/>
+          </a:lnRef>
+          <a:fillRef idx="3">
+            <a:schemeClr val="accent1"/>
+          </a:fillRef>
+          <a:effectRef idx="2">
+            <a:schemeClr val="accent1"/>
+          </a:effectRef>
+          <a:fontRef idx="minor">
+            <a:schemeClr val="lt1"/>
+          </a:fontRef>
+        </p:style>
+        <p:txBody>
+          <a:bodyPr rtlCol="0" anchor="ctr"/>
+          <a:lstStyle/>
+          <a:p>
+            <a:pPr algn="ctr">
+              <a:defRPr sz="700" b="0">
+                <a:solidFill>
+                  <a:srgbClr val="CCCCCC"/>
+                </a:solidFill>
+                <a:latin typeface="Calibri"/>
+              </a:defRPr>
+            </a:pPr>
+            <a:r>
+              <a:t>2,500</a:t>
+            </a:r>
+          </a:p>
+        </p:txBody>
+      </p:sp>
+      <p:sp>
+        <p:nvSpPr>
+          <p:cNvPr id="31" name="Rectangle 30"/>
+          <p:cNvSpPr/>
+          <p:nvPr/>
+        </p:nvSpPr>
+        <p:spPr>
+          <a:xfrm>
+            <a:off x="6949440" y="3547872"/>
+            <a:ext cx="1828800" cy="237744"/>
+          </a:xfrm>
+          <a:prstGeom prst="rect">
+            <a:avLst/>
+          </a:prstGeom>
+          <a:solidFill>
+            <a:srgbClr val="1A1A2E"/>
+          </a:solidFill>
+          <a:ln w="12700">
+            <a:solidFill>
+              <a:srgbClr val="2A2A3E"/>
+            </a:solidFill>
+          </a:ln>
+        </p:spPr>
+        <p:style>
+          <a:lnRef idx="1">
+            <a:schemeClr val="accent1"/>
+          </a:lnRef>
+          <a:fillRef idx="3">
+            <a:schemeClr val="accent1"/>
+          </a:fillRef>
+          <a:effectRef idx="2">
+            <a:schemeClr val="accent1"/>
+          </a:effectRef>
+          <a:fontRef idx="minor">
+            <a:schemeClr val="lt1"/>
+          </a:fontRef>
+        </p:style>
+        <p:txBody>
+          <a:bodyPr rtlCol="0" anchor="ctr"/>
+          <a:lstStyle/>
+          <a:p>
+            <a:pPr algn="ctr">
+              <a:defRPr sz="700" b="0">
+                <a:solidFill>
+                  <a:srgbClr val="CCCCCC"/>
+                </a:solidFill>
+                <a:latin typeface="Calibri"/>
+              </a:defRPr>
+            </a:pPr>
+            <a:r>
+              <a:t>16,000</a:t>
+            </a:r>
+          </a:p>
+        </p:txBody>
+      </p:sp>
+      <p:sp>
+        <p:nvSpPr>
+          <p:cNvPr id="32" name="Rectangle 31"/>
+          <p:cNvSpPr/>
+          <p:nvPr/>
+        </p:nvSpPr>
+        <p:spPr>
+          <a:xfrm>
+            <a:off x="731520" y="3785616"/>
+            <a:ext cx="2560320" cy="237744"/>
+          </a:xfrm>
+          <a:prstGeom prst="rect">
+            <a:avLst/>
+          </a:prstGeom>
+          <a:solidFill>
+            <a:srgbClr val="151528"/>
+          </a:solidFill>
+          <a:ln w="12700">
+            <a:solidFill>
+              <a:srgbClr val="2A2A3E"/>
+            </a:solidFill>
+          </a:ln>
+        </p:spPr>
+        <p:style>
+          <a:lnRef idx="1">
+            <a:schemeClr val="accent1"/>
+          </a:lnRef>
+          <a:fillRef idx="3">
+            <a:schemeClr val="accent1"/>
+          </a:fillRef>
+          <a:effectRef idx="2">
+            <a:schemeClr val="accent1"/>
+          </a:effectRef>
+          <a:fontRef idx="minor">
+            <a:schemeClr val="lt1"/>
+          </a:fontRef>
+        </p:style>
+        <p:txBody>
+          <a:bodyPr rtlCol="0" anchor="ctr"/>
+          <a:lstStyle/>
+          <a:p>
+            <a:pPr algn="ctr">
+              <a:defRPr sz="700" b="0">
+                <a:solidFill>
+                  <a:srgbClr val="CCCCCC"/>
+                </a:solidFill>
+                <a:latin typeface="Calibri"/>
+              </a:defRPr>
+            </a:pPr>
+            <a:r>
+              <a:t>ARPU (Monthly)</a:t>
+            </a:r>
+          </a:p>
+        </p:txBody>
+      </p:sp>
+      <p:sp>
+        <p:nvSpPr>
+          <p:cNvPr id="33" name="Rectangle 32"/>
+          <p:cNvSpPr/>
+          <p:nvPr/>
+        </p:nvSpPr>
+        <p:spPr>
+          <a:xfrm>
+            <a:off x="3291840" y="3785616"/>
+            <a:ext cx="1828800" cy="237744"/>
+          </a:xfrm>
+          <a:prstGeom prst="rect">
+            <a:avLst/>
+          </a:prstGeom>
+          <a:solidFill>
+            <a:srgbClr val="151528"/>
+          </a:solidFill>
+          <a:ln w="12700">
+            <a:solidFill>
+              <a:srgbClr val="2A2A3E"/>
+            </a:solidFill>
+          </a:ln>
+        </p:spPr>
+        <p:style>
+          <a:lnRef idx="1">
+            <a:schemeClr val="accent1"/>
+          </a:lnRef>
+          <a:fillRef idx="3">
+            <a:schemeClr val="accent1"/>
+          </a:fillRef>
+          <a:effectRef idx="2">
+            <a:schemeClr val="accent1"/>
+          </a:effectRef>
+          <a:fontRef idx="minor">
+            <a:schemeClr val="lt1"/>
+          </a:fontRef>
+        </p:style>
+        <p:txBody>
+          <a:bodyPr rtlCol="0" anchor="ctr"/>
+          <a:lstStyle/>
+          <a:p>
+            <a:pPr algn="ctr">
+              <a:defRPr sz="700" b="0">
+                <a:solidFill>
+                  <a:srgbClr val="CCCCCC"/>
+                </a:solidFill>
+                <a:latin typeface="Calibri"/>
+              </a:defRPr>
+            </a:pPr>
+            <a:r>
+              <a:t>Rs.199</a:t>
+            </a:r>
+          </a:p>
+        </p:txBody>
+      </p:sp>
+      <p:sp>
+        <p:nvSpPr>
+          <p:cNvPr id="34" name="Rectangle 33"/>
+          <p:cNvSpPr/>
+          <p:nvPr/>
+        </p:nvSpPr>
+        <p:spPr>
+          <a:xfrm>
+            <a:off x="5120640" y="3785616"/>
+            <a:ext cx="1828800" cy="237744"/>
+          </a:xfrm>
+          <a:prstGeom prst="rect">
+            <a:avLst/>
+          </a:prstGeom>
+          <a:solidFill>
+            <a:srgbClr val="151528"/>
+          </a:solidFill>
+          <a:ln w="12700">
+            <a:solidFill>
+              <a:srgbClr val="2A2A3E"/>
+            </a:solidFill>
+          </a:ln>
+        </p:spPr>
+        <p:style>
+          <a:lnRef idx="1">
+            <a:schemeClr val="accent1"/>
+          </a:lnRef>
+          <a:fillRef idx="3">
+            <a:schemeClr val="accent1"/>
+          </a:fillRef>
+          <a:effectRef idx="2">
+            <a:schemeClr val="accent1"/>
+          </a:effectRef>
+          <a:fontRef idx="minor">
+            <a:schemeClr val="lt1"/>
+          </a:fontRef>
+        </p:style>
+        <p:txBody>
+          <a:bodyPr rtlCol="0" anchor="ctr"/>
+          <a:lstStyle/>
+          <a:p>
+            <a:pPr algn="ctr">
+              <a:defRPr sz="700" b="0">
+                <a:solidFill>
+                  <a:srgbClr val="CCCCCC"/>
+                </a:solidFill>
+                <a:latin typeface="Calibri"/>
+              </a:defRPr>
+            </a:pPr>
+            <a:r>
+              <a:t>Rs.249</a:t>
+            </a:r>
+          </a:p>
+        </p:txBody>
+      </p:sp>
+      <p:sp>
+        <p:nvSpPr>
+          <p:cNvPr id="35" name="Rectangle 34"/>
+          <p:cNvSpPr/>
+          <p:nvPr/>
+        </p:nvSpPr>
+        <p:spPr>
+          <a:xfrm>
+            <a:off x="6949440" y="3785616"/>
+            <a:ext cx="1828800" cy="237744"/>
+          </a:xfrm>
+          <a:prstGeom prst="rect">
+            <a:avLst/>
+          </a:prstGeom>
+          <a:solidFill>
+            <a:srgbClr val="151528"/>
+          </a:solidFill>
+          <a:ln w="12700">
+            <a:solidFill>
+              <a:srgbClr val="2A2A3E"/>
+            </a:solidFill>
+          </a:ln>
+        </p:spPr>
+        <p:style>
+          <a:lnRef idx="1">
+            <a:schemeClr val="accent1"/>
+          </a:lnRef>
+          <a:fillRef idx="3">
+            <a:schemeClr val="accent1"/>
+          </a:fillRef>
+          <a:effectRef idx="2">
+            <a:schemeClr val="accent1"/>
+          </a:effectRef>
+          <a:fontRef idx="minor">
+            <a:schemeClr val="lt1"/>
+          </a:fontRef>
+        </p:style>
+        <p:txBody>
+          <a:bodyPr rtlCol="0" anchor="ctr"/>
+          <a:lstStyle/>
+          <a:p>
+            <a:pPr algn="ctr">
+              <a:defRPr sz="700" b="0">
+                <a:solidFill>
+                  <a:srgbClr val="CCCCCC"/>
+                </a:solidFill>
+                <a:latin typeface="Calibri"/>
+              </a:defRPr>
+            </a:pPr>
+            <a:r>
+              <a:t>Rs.299</a:t>
+            </a:r>
+          </a:p>
+        </p:txBody>
+      </p:sp>
+      <p:sp>
+        <p:nvSpPr>
+          <p:cNvPr id="36" name="Rectangle 35"/>
+          <p:cNvSpPr/>
+          <p:nvPr/>
+        </p:nvSpPr>
+        <p:spPr>
+          <a:xfrm>
+            <a:off x="731520" y="4023360"/>
+            <a:ext cx="2560320" cy="237744"/>
+          </a:xfrm>
+          <a:prstGeom prst="rect">
+            <a:avLst/>
+          </a:prstGeom>
+          <a:solidFill>
+            <a:srgbClr val="15152A"/>
+          </a:solidFill>
+          <a:ln w="12700">
+            <a:solidFill>
+              <a:srgbClr val="2A2A3E"/>
+            </a:solidFill>
+          </a:ln>
+        </p:spPr>
+        <p:style>
+          <a:lnRef idx="1">
+            <a:schemeClr val="accent1"/>
+          </a:lnRef>
+          <a:fillRef idx="3">
+            <a:schemeClr val="accent1"/>
+          </a:fillRef>
+          <a:effectRef idx="2">
+            <a:schemeClr val="accent1"/>
+          </a:effectRef>
+          <a:fontRef idx="minor">
+            <a:schemeClr val="lt1"/>
+          </a:fontRef>
+        </p:style>
+        <p:txBody>
+          <a:bodyPr rtlCol="0" anchor="ctr"/>
+          <a:lstStyle/>
+          <a:p>
+            <a:pPr algn="ctr">
+              <a:defRPr sz="700" b="1">
+                <a:solidFill>
+                  <a:srgbClr val="C4B5FD"/>
+                </a:solidFill>
+                <a:latin typeface="Calibri"/>
+              </a:defRPr>
+            </a:pPr>
+            <a:r>
+              <a:t>Subscription Revenue</a:t>
+            </a:r>
+          </a:p>
+        </p:txBody>
+      </p:sp>
+      <p:sp>
+        <p:nvSpPr>
+          <p:cNvPr id="37" name="Rectangle 36"/>
+          <p:cNvSpPr/>
+          <p:nvPr/>
+        </p:nvSpPr>
+        <p:spPr>
+          <a:xfrm>
+            <a:off x="3291840" y="4023360"/>
+            <a:ext cx="1828800" cy="237744"/>
+          </a:xfrm>
+          <a:prstGeom prst="rect">
+            <a:avLst/>
+          </a:prstGeom>
+          <a:solidFill>
+            <a:srgbClr val="15152A"/>
+          </a:solidFill>
+          <a:ln w="12700">
+            <a:solidFill>
+              <a:srgbClr val="2A2A3E"/>
+            </a:solidFill>
+          </a:ln>
+        </p:spPr>
+        <p:style>
+          <a:lnRef idx="1">
+            <a:schemeClr val="accent1"/>
+          </a:lnRef>
+          <a:fillRef idx="3">
+            <a:schemeClr val="accent1"/>
+          </a:fillRef>
+          <a:effectRef idx="2">
+            <a:schemeClr val="accent1"/>
+          </a:effectRef>
+          <a:fontRef idx="minor">
+            <a:schemeClr val="lt1"/>
+          </a:fontRef>
+        </p:style>
+        <p:txBody>
+          <a:bodyPr rtlCol="0" anchor="ctr"/>
+          <a:lstStyle/>
+          <a:p>
+            <a:pPr algn="ctr">
+              <a:defRPr sz="700" b="1">
+                <a:solidFill>
+                  <a:srgbClr val="C4B5FD"/>
+                </a:solidFill>
+                <a:latin typeface="Calibri"/>
+              </a:defRPr>
+            </a:pPr>
+            <a:r>
+              <a:t>Rs.11.9L</a:t>
+            </a:r>
+          </a:p>
+        </p:txBody>
+      </p:sp>
+      <p:sp>
+        <p:nvSpPr>
+          <p:cNvPr id="38" name="Rectangle 37"/>
+          <p:cNvSpPr/>
+          <p:nvPr/>
+        </p:nvSpPr>
+        <p:spPr>
+          <a:xfrm>
+            <a:off x="5120640" y="4023360"/>
+            <a:ext cx="1828800" cy="237744"/>
+          </a:xfrm>
+          <a:prstGeom prst="rect">
+            <a:avLst/>
+          </a:prstGeom>
+          <a:solidFill>
+            <a:srgbClr val="15152A"/>
+          </a:solidFill>
+          <a:ln w="12700">
+            <a:solidFill>
+              <a:srgbClr val="2A2A3E"/>
+            </a:solidFill>
+          </a:ln>
+        </p:spPr>
+        <p:style>
+          <a:lnRef idx="1">
+            <a:schemeClr val="accent1"/>
+          </a:lnRef>
+          <a:fillRef idx="3">
+            <a:schemeClr val="accent1"/>
+          </a:fillRef>
+          <a:effectRef idx="2">
+            <a:schemeClr val="accent1"/>
+          </a:effectRef>
+          <a:fontRef idx="minor">
+            <a:schemeClr val="lt1"/>
+          </a:fontRef>
+        </p:style>
+        <p:txBody>
+          <a:bodyPr rtlCol="0" anchor="ctr"/>
+          <a:lstStyle/>
+          <a:p>
+            <a:pPr algn="ctr">
+              <a:defRPr sz="700" b="1">
+                <a:solidFill>
+                  <a:srgbClr val="C4B5FD"/>
+                </a:solidFill>
+                <a:latin typeface="Calibri"/>
+              </a:defRPr>
+            </a:pPr>
+            <a:r>
+              <a:t>Rs.74.7L</a:t>
+            </a:r>
+          </a:p>
+        </p:txBody>
+      </p:sp>
+      <p:sp>
+        <p:nvSpPr>
+          <p:cNvPr id="39" name="Rectangle 38"/>
+          <p:cNvSpPr/>
+          <p:nvPr/>
+        </p:nvSpPr>
+        <p:spPr>
+          <a:xfrm>
+            <a:off x="6949440" y="4023360"/>
+            <a:ext cx="1828800" cy="237744"/>
+          </a:xfrm>
+          <a:prstGeom prst="rect">
+            <a:avLst/>
+          </a:prstGeom>
+          <a:solidFill>
+            <a:srgbClr val="15152A"/>
+          </a:solidFill>
+          <a:ln w="12700">
+            <a:solidFill>
+              <a:srgbClr val="2A2A3E"/>
+            </a:solidFill>
+          </a:ln>
+        </p:spPr>
+        <p:style>
+          <a:lnRef idx="1">
+            <a:schemeClr val="accent1"/>
+          </a:lnRef>
+          <a:fillRef idx="3">
+            <a:schemeClr val="accent1"/>
+          </a:fillRef>
+          <a:effectRef idx="2">
+            <a:schemeClr val="accent1"/>
+          </a:effectRef>
+          <a:fontRef idx="minor">
+            <a:schemeClr val="lt1"/>
+          </a:fontRef>
+        </p:style>
+        <p:txBody>
+          <a:bodyPr rtlCol="0" anchor="ctr"/>
+          <a:lstStyle/>
+          <a:p>
+            <a:pPr algn="ctr">
+              <a:defRPr sz="700" b="1">
+                <a:solidFill>
+                  <a:srgbClr val="C4B5FD"/>
+                </a:solidFill>
+                <a:latin typeface="Calibri"/>
+              </a:defRPr>
+            </a:pPr>
+            <a:r>
+              <a:t>Rs.5.74Cr</a:t>
+            </a:r>
+          </a:p>
+        </p:txBody>
+      </p:sp>
+      <p:sp>
+        <p:nvSpPr>
+          <p:cNvPr id="40" name="Rectangle 39"/>
+          <p:cNvSpPr/>
+          <p:nvPr/>
+        </p:nvSpPr>
+        <p:spPr>
+          <a:xfrm>
+            <a:off x="731520" y="4261104"/>
+            <a:ext cx="2560320" cy="237744"/>
+          </a:xfrm>
+          <a:prstGeom prst="rect">
+            <a:avLst/>
+          </a:prstGeom>
+          <a:solidFill>
+            <a:srgbClr val="151528"/>
+          </a:solidFill>
+          <a:ln w="12700">
+            <a:solidFill>
+              <a:srgbClr val="2A2A3E"/>
+            </a:solidFill>
+          </a:ln>
+        </p:spPr>
+        <p:style>
+          <a:lnRef idx="1">
+            <a:schemeClr val="accent1"/>
+          </a:lnRef>
+          <a:fillRef idx="3">
+            <a:schemeClr val="accent1"/>
+          </a:fillRef>
+          <a:effectRef idx="2">
+            <a:schemeClr val="accent1"/>
+          </a:effectRef>
+          <a:fontRef idx="minor">
+            <a:schemeClr val="lt1"/>
+          </a:fontRef>
+        </p:style>
+        <p:txBody>
+          <a:bodyPr rtlCol="0" anchor="ctr"/>
+          <a:lstStyle/>
+          <a:p>
+            <a:pPr algn="ctr">
+              <a:defRPr sz="700" b="0">
+                <a:solidFill>
+                  <a:srgbClr val="CCCCCC"/>
+                </a:solidFill>
+                <a:latin typeface="Calibri"/>
+              </a:defRPr>
+            </a:pPr>
+            <a:r>
+              <a:t>Coaching SaaS</a:t>
+            </a:r>
+          </a:p>
+        </p:txBody>
+      </p:sp>
+      <p:sp>
+        <p:nvSpPr>
+          <p:cNvPr id="41" name="Rectangle 40"/>
+          <p:cNvSpPr/>
+          <p:nvPr/>
+        </p:nvSpPr>
+        <p:spPr>
+          <a:xfrm>
+            <a:off x="3291840" y="4261104"/>
+            <a:ext cx="1828800" cy="237744"/>
+          </a:xfrm>
+          <a:prstGeom prst="rect">
+            <a:avLst/>
+          </a:prstGeom>
+          <a:solidFill>
+            <a:srgbClr val="151528"/>
+          </a:solidFill>
+          <a:ln w="12700">
+            <a:solidFill>
+              <a:srgbClr val="2A2A3E"/>
+            </a:solidFill>
+          </a:ln>
+        </p:spPr>
+        <p:style>
+          <a:lnRef idx="1">
+            <a:schemeClr val="accent1"/>
+          </a:lnRef>
+          <a:fillRef idx="3">
+            <a:schemeClr val="accent1"/>
+          </a:fillRef>
+          <a:effectRef idx="2">
+            <a:schemeClr val="accent1"/>
+          </a:effectRef>
+          <a:fontRef idx="minor">
+            <a:schemeClr val="lt1"/>
+          </a:fontRef>
+        </p:style>
+        <p:txBody>
+          <a:bodyPr rtlCol="0" anchor="ctr"/>
+          <a:lstStyle/>
+          <a:p>
+            <a:pPr algn="ctr">
+              <a:defRPr sz="700" b="0">
+                <a:solidFill>
+                  <a:srgbClr val="CCCCCC"/>
+                </a:solidFill>
+                <a:latin typeface="Calibri"/>
+              </a:defRPr>
+            </a:pPr>
+            <a:r>
+              <a:t>Rs.0</a:t>
+            </a:r>
+          </a:p>
+        </p:txBody>
+      </p:sp>
+      <p:sp>
+        <p:nvSpPr>
+          <p:cNvPr id="42" name="Rectangle 41"/>
+          <p:cNvSpPr/>
+          <p:nvPr/>
+        </p:nvSpPr>
+        <p:spPr>
+          <a:xfrm>
+            <a:off x="5120640" y="4261104"/>
+            <a:ext cx="1828800" cy="237744"/>
+          </a:xfrm>
+          <a:prstGeom prst="rect">
+            <a:avLst/>
+          </a:prstGeom>
+          <a:solidFill>
+            <a:srgbClr val="151528"/>
+          </a:solidFill>
+          <a:ln w="12700">
+            <a:solidFill>
+              <a:srgbClr val="2A2A3E"/>
+            </a:solidFill>
+          </a:ln>
+        </p:spPr>
+        <p:style>
+          <a:lnRef idx="1">
+            <a:schemeClr val="accent1"/>
+          </a:lnRef>
+          <a:fillRef idx="3">
+            <a:schemeClr val="accent1"/>
+          </a:fillRef>
+          <a:effectRef idx="2">
+            <a:schemeClr val="accent1"/>
+          </a:effectRef>
+          <a:fontRef idx="minor">
+            <a:schemeClr val="lt1"/>
+          </a:fontRef>
+        </p:style>
+        <p:txBody>
+          <a:bodyPr rtlCol="0" anchor="ctr"/>
+          <a:lstStyle/>
+          <a:p>
+            <a:pPr algn="ctr">
+              <a:defRPr sz="700" b="0">
+                <a:solidFill>
+                  <a:srgbClr val="CCCCCC"/>
+                </a:solidFill>
+                <a:latin typeface="Calibri"/>
+              </a:defRPr>
+            </a:pPr>
+            <a:r>
+              <a:t>Rs.15L</a:t>
+            </a:r>
+          </a:p>
+        </p:txBody>
+      </p:sp>
+      <p:sp>
+        <p:nvSpPr>
+          <p:cNvPr id="43" name="Rectangle 42"/>
+          <p:cNvSpPr/>
+          <p:nvPr/>
+        </p:nvSpPr>
+        <p:spPr>
+          <a:xfrm>
+            <a:off x="6949440" y="4261104"/>
+            <a:ext cx="1828800" cy="237744"/>
+          </a:xfrm>
+          <a:prstGeom prst="rect">
+            <a:avLst/>
+          </a:prstGeom>
+          <a:solidFill>
+            <a:srgbClr val="151528"/>
+          </a:solidFill>
+          <a:ln w="12700">
+            <a:solidFill>
+              <a:srgbClr val="2A2A3E"/>
+            </a:solidFill>
+          </a:ln>
+        </p:spPr>
+        <p:style>
+          <a:lnRef idx="1">
+            <a:schemeClr val="accent1"/>
+          </a:lnRef>
+          <a:fillRef idx="3">
+            <a:schemeClr val="accent1"/>
+          </a:fillRef>
+          <a:effectRef idx="2">
+            <a:schemeClr val="accent1"/>
+          </a:effectRef>
+          <a:fontRef idx="minor">
+            <a:schemeClr val="lt1"/>
+          </a:fontRef>
+        </p:style>
+        <p:txBody>
+          <a:bodyPr rtlCol="0" anchor="ctr"/>
+          <a:lstStyle/>
+          <a:p>
+            <a:pPr algn="ctr">
+              <a:defRPr sz="700" b="0">
+                <a:solidFill>
+                  <a:srgbClr val="CCCCCC"/>
+                </a:solidFill>
+                <a:latin typeface="Calibri"/>
+              </a:defRPr>
+            </a:pPr>
+            <a:r>
+              <a:t>Rs.75L</a:t>
+            </a:r>
+          </a:p>
+        </p:txBody>
+      </p:sp>
+      <p:sp>
+        <p:nvSpPr>
+          <p:cNvPr id="44" name="Rectangle 43"/>
+          <p:cNvSpPr/>
+          <p:nvPr/>
+        </p:nvSpPr>
+        <p:spPr>
+          <a:xfrm>
+            <a:off x="731520" y="4498848"/>
+            <a:ext cx="2560320" cy="237744"/>
+          </a:xfrm>
+          <a:prstGeom prst="rect">
+            <a:avLst/>
+          </a:prstGeom>
+          <a:solidFill>
+            <a:srgbClr val="1A1A2E"/>
+          </a:solidFill>
+          <a:ln w="12700">
+            <a:solidFill>
+              <a:srgbClr val="2A2A3E"/>
+            </a:solidFill>
+          </a:ln>
+        </p:spPr>
+        <p:style>
+          <a:lnRef idx="1">
+            <a:schemeClr val="accent1"/>
+          </a:lnRef>
+          <a:fillRef idx="3">
+            <a:schemeClr val="accent1"/>
+          </a:fillRef>
+          <a:effectRef idx="2">
+            <a:schemeClr val="accent1"/>
+          </a:effectRef>
+          <a:fontRef idx="minor">
+            <a:schemeClr val="lt1"/>
+          </a:fontRef>
+        </p:style>
+        <p:txBody>
+          <a:bodyPr rtlCol="0" anchor="ctr"/>
+          <a:lstStyle/>
+          <a:p>
+            <a:pPr algn="ctr">
+              <a:defRPr sz="700" b="0">
+                <a:solidFill>
+                  <a:srgbClr val="CCCCCC"/>
+                </a:solidFill>
+                <a:latin typeface="Calibri"/>
+              </a:defRPr>
+            </a:pPr>
+            <a:r>
+              <a:t>Enterprise</a:t>
+            </a:r>
+          </a:p>
+        </p:txBody>
+      </p:sp>
+      <p:sp>
+        <p:nvSpPr>
+          <p:cNvPr id="45" name="Rectangle 44"/>
+          <p:cNvSpPr/>
+          <p:nvPr/>
+        </p:nvSpPr>
+        <p:spPr>
+          <a:xfrm>
+            <a:off x="3291840" y="4498848"/>
+            <a:ext cx="1828800" cy="237744"/>
+          </a:xfrm>
+          <a:prstGeom prst="rect">
+            <a:avLst/>
+          </a:prstGeom>
+          <a:solidFill>
+            <a:srgbClr val="1A1A2E"/>
+          </a:solidFill>
+          <a:ln w="12700">
+            <a:solidFill>
+              <a:srgbClr val="2A2A3E"/>
+            </a:solidFill>
+          </a:ln>
+        </p:spPr>
+        <p:style>
+          <a:lnRef idx="1">
+            <a:schemeClr val="accent1"/>
+          </a:lnRef>
+          <a:fillRef idx="3">
+            <a:schemeClr val="accent1"/>
+          </a:fillRef>
+          <a:effectRef idx="2">
+            <a:schemeClr val="accent1"/>
+          </a:effectRef>
+          <a:fontRef idx="minor">
+            <a:schemeClr val="lt1"/>
+          </a:fontRef>
+        </p:style>
+        <p:txBody>
+          <a:bodyPr rtlCol="0" anchor="ctr"/>
+          <a:lstStyle/>
+          <a:p>
+            <a:pPr algn="ctr">
+              <a:defRPr sz="700" b="0">
+                <a:solidFill>
+                  <a:srgbClr val="CCCCCC"/>
+                </a:solidFill>
+                <a:latin typeface="Calibri"/>
+              </a:defRPr>
+            </a:pPr>
+            <a:r>
+              <a:t>Rs.0</a:t>
+            </a:r>
+          </a:p>
+        </p:txBody>
+      </p:sp>
+      <p:sp>
+        <p:nvSpPr>
+          <p:cNvPr id="46" name="Rectangle 45"/>
+          <p:cNvSpPr/>
+          <p:nvPr/>
+        </p:nvSpPr>
+        <p:spPr>
+          <a:xfrm>
+            <a:off x="5120640" y="4498848"/>
+            <a:ext cx="1828800" cy="237744"/>
+          </a:xfrm>
+          <a:prstGeom prst="rect">
+            <a:avLst/>
+          </a:prstGeom>
+          <a:solidFill>
+            <a:srgbClr val="1A1A2E"/>
+          </a:solidFill>
+          <a:ln w="12700">
+            <a:solidFill>
+              <a:srgbClr val="2A2A3E"/>
+            </a:solidFill>
+          </a:ln>
+        </p:spPr>
+        <p:style>
+          <a:lnRef idx="1">
+            <a:schemeClr val="accent1"/>
+          </a:lnRef>
+          <a:fillRef idx="3">
+            <a:schemeClr val="accent1"/>
+          </a:fillRef>
+          <a:effectRef idx="2">
+            <a:schemeClr val="accent1"/>
+          </a:effectRef>
+          <a:fontRef idx="minor">
+            <a:schemeClr val="lt1"/>
+          </a:fontRef>
+        </p:style>
+        <p:txBody>
+          <a:bodyPr rtlCol="0" anchor="ctr"/>
+          <a:lstStyle/>
+          <a:p>
+            <a:pPr algn="ctr">
+              <a:defRPr sz="700" b="0">
+                <a:solidFill>
+                  <a:srgbClr val="CCCCCC"/>
+                </a:solidFill>
+                <a:latin typeface="Calibri"/>
+              </a:defRPr>
+            </a:pPr>
+            <a:r>
+              <a:t>Rs.5L</a:t>
+            </a:r>
+          </a:p>
+        </p:txBody>
+      </p:sp>
+      <p:sp>
+        <p:nvSpPr>
+          <p:cNvPr id="47" name="Rectangle 46"/>
+          <p:cNvSpPr/>
+          <p:nvPr/>
+        </p:nvSpPr>
+        <p:spPr>
+          <a:xfrm>
+            <a:off x="6949440" y="4498848"/>
+            <a:ext cx="1828800" cy="237744"/>
+          </a:xfrm>
+          <a:prstGeom prst="rect">
+            <a:avLst/>
+          </a:prstGeom>
+          <a:solidFill>
+            <a:srgbClr val="1A1A2E"/>
+          </a:solidFill>
+          <a:ln w="12700">
+            <a:solidFill>
+              <a:srgbClr val="2A2A3E"/>
+            </a:solidFill>
+          </a:ln>
+        </p:spPr>
+        <p:style>
+          <a:lnRef idx="1">
+            <a:schemeClr val="accent1"/>
+          </a:lnRef>
+          <a:fillRef idx="3">
+            <a:schemeClr val="accent1"/>
+          </a:fillRef>
+          <a:effectRef idx="2">
+            <a:schemeClr val="accent1"/>
+          </a:effectRef>
+          <a:fontRef idx="minor">
+            <a:schemeClr val="lt1"/>
+          </a:fontRef>
+        </p:style>
+        <p:txBody>
+          <a:bodyPr rtlCol="0" anchor="ctr"/>
+          <a:lstStyle/>
+          <a:p>
+            <a:pPr algn="ctr">
+              <a:defRPr sz="700" b="0">
+                <a:solidFill>
+                  <a:srgbClr val="CCCCCC"/>
+                </a:solidFill>
+                <a:latin typeface="Calibri"/>
+              </a:defRPr>
+            </a:pPr>
+            <a:r>
+              <a:t>Rs.30L</a:t>
+            </a:r>
+          </a:p>
+        </p:txBody>
+      </p:sp>
+      <p:sp>
+        <p:nvSpPr>
+          <p:cNvPr id="48" name="Rectangle 47"/>
+          <p:cNvSpPr/>
+          <p:nvPr/>
+        </p:nvSpPr>
+        <p:spPr>
+          <a:xfrm>
+            <a:off x="731520" y="4736592"/>
+            <a:ext cx="2560320" cy="237744"/>
+          </a:xfrm>
+          <a:prstGeom prst="rect">
+            <a:avLst/>
+          </a:prstGeom>
+          <a:solidFill>
+            <a:srgbClr val="151528"/>
+          </a:solidFill>
+          <a:ln w="12700">
+            <a:solidFill>
+              <a:srgbClr val="2A2A3E"/>
+            </a:solidFill>
+          </a:ln>
+        </p:spPr>
+        <p:style>
+          <a:lnRef idx="1">
+            <a:schemeClr val="accent1"/>
+          </a:lnRef>
+          <a:fillRef idx="3">
+            <a:schemeClr val="accent1"/>
+          </a:fillRef>
+          <a:effectRef idx="2">
+            <a:schemeClr val="accent1"/>
+          </a:effectRef>
+          <a:fontRef idx="minor">
+            <a:schemeClr val="lt1"/>
+          </a:fontRef>
+        </p:style>
+        <p:txBody>
+          <a:bodyPr rtlCol="0" anchor="ctr"/>
+          <a:lstStyle/>
+          <a:p>
+            <a:pPr algn="ctr">
+              <a:defRPr sz="700" b="0">
+                <a:solidFill>
+                  <a:srgbClr val="CCCCCC"/>
+                </a:solidFill>
+                <a:latin typeface="Calibri"/>
+              </a:defRPr>
+            </a:pPr>
+            <a:r>
+              <a:t>Marketplace</a:t>
+            </a:r>
+          </a:p>
+        </p:txBody>
+      </p:sp>
+      <p:sp>
+        <p:nvSpPr>
+          <p:cNvPr id="49" name="Rectangle 48"/>
+          <p:cNvSpPr/>
+          <p:nvPr/>
+        </p:nvSpPr>
+        <p:spPr>
+          <a:xfrm>
+            <a:off x="3291840" y="4736592"/>
+            <a:ext cx="1828800" cy="237744"/>
+          </a:xfrm>
+          <a:prstGeom prst="rect">
+            <a:avLst/>
+          </a:prstGeom>
+          <a:solidFill>
+            <a:srgbClr val="151528"/>
+          </a:solidFill>
+          <a:ln w="12700">
+            <a:solidFill>
+              <a:srgbClr val="2A2A3E"/>
+            </a:solidFill>
+          </a:ln>
+        </p:spPr>
+        <p:style>
+          <a:lnRef idx="1">
+            <a:schemeClr val="accent1"/>
+          </a:lnRef>
+          <a:fillRef idx="3">
+            <a:schemeClr val="accent1"/>
+          </a:fillRef>
+          <a:effectRef idx="2">
+            <a:schemeClr val="accent1"/>
+          </a:effectRef>
+          <a:fontRef idx="minor">
+            <a:schemeClr val="lt1"/>
+          </a:fontRef>
+        </p:style>
+        <p:txBody>
+          <a:bodyPr rtlCol="0" anchor="ctr"/>
+          <a:lstStyle/>
+          <a:p>
+            <a:pPr algn="ctr">
+              <a:defRPr sz="700" b="0">
+                <a:solidFill>
+                  <a:srgbClr val="CCCCCC"/>
+                </a:solidFill>
+                <a:latin typeface="Calibri"/>
+              </a:defRPr>
+            </a:pPr>
+            <a:r>
+              <a:t>Rs.0</a:t>
+            </a:r>
+          </a:p>
+        </p:txBody>
+      </p:sp>
+      <p:sp>
+        <p:nvSpPr>
+          <p:cNvPr id="50" name="Rectangle 49"/>
+          <p:cNvSpPr/>
+          <p:nvPr/>
+        </p:nvSpPr>
+        <p:spPr>
+          <a:xfrm>
+            <a:off x="5120640" y="4736592"/>
+            <a:ext cx="1828800" cy="237744"/>
+          </a:xfrm>
+          <a:prstGeom prst="rect">
+            <a:avLst/>
+          </a:prstGeom>
+          <a:solidFill>
+            <a:srgbClr val="151528"/>
+          </a:solidFill>
+          <a:ln w="12700">
+            <a:solidFill>
+              <a:srgbClr val="2A2A3E"/>
+            </a:solidFill>
+          </a:ln>
+        </p:spPr>
+        <p:style>
+          <a:lnRef idx="1">
+            <a:schemeClr val="accent1"/>
+          </a:lnRef>
+          <a:fillRef idx="3">
+            <a:schemeClr val="accent1"/>
+          </a:fillRef>
+          <a:effectRef idx="2">
+            <a:schemeClr val="accent1"/>
+          </a:effectRef>
+          <a:fontRef idx="minor">
+            <a:schemeClr val="lt1"/>
+          </a:fontRef>
+        </p:style>
+        <p:txBody>
+          <a:bodyPr rtlCol="0" anchor="ctr"/>
+          <a:lstStyle/>
+          <a:p>
+            <a:pPr algn="ctr">
+              <a:defRPr sz="700" b="0">
+                <a:solidFill>
+                  <a:srgbClr val="CCCCCC"/>
+                </a:solidFill>
+                <a:latin typeface="Calibri"/>
+              </a:defRPr>
+            </a:pPr>
+            <a:r>
+              <a:t>Rs.2L</a:t>
+            </a:r>
+          </a:p>
+        </p:txBody>
+      </p:sp>
+      <p:sp>
+        <p:nvSpPr>
+          <p:cNvPr id="51" name="Rectangle 50"/>
+          <p:cNvSpPr/>
+          <p:nvPr/>
+        </p:nvSpPr>
+        <p:spPr>
+          <a:xfrm>
+            <a:off x="6949440" y="4736592"/>
+            <a:ext cx="1828800" cy="237744"/>
+          </a:xfrm>
+          <a:prstGeom prst="rect">
+            <a:avLst/>
+          </a:prstGeom>
+          <a:solidFill>
+            <a:srgbClr val="151528"/>
+          </a:solidFill>
+          <a:ln w="12700">
+            <a:solidFill>
+              <a:srgbClr val="2A2A3E"/>
+            </a:solidFill>
+          </a:ln>
+        </p:spPr>
+        <p:style>
+          <a:lnRef idx="1">
+            <a:schemeClr val="accent1"/>
+          </a:lnRef>
+          <a:fillRef idx="3">
+            <a:schemeClr val="accent1"/>
+          </a:fillRef>
+          <a:effectRef idx="2">
+            <a:schemeClr val="accent1"/>
+          </a:effectRef>
+          <a:fontRef idx="minor">
+            <a:schemeClr val="lt1"/>
+          </a:fontRef>
+        </p:style>
+        <p:txBody>
+          <a:bodyPr rtlCol="0" anchor="ctr"/>
+          <a:lstStyle/>
+          <a:p>
+            <a:pPr algn="ctr">
+              <a:defRPr sz="700" b="0">
+                <a:solidFill>
+                  <a:srgbClr val="CCCCCC"/>
+                </a:solidFill>
+                <a:latin typeface="Calibri"/>
+              </a:defRPr>
+            </a:pPr>
+            <a:r>
+              <a:t>Rs.20L</a:t>
+            </a:r>
+          </a:p>
+        </p:txBody>
+      </p:sp>
+      <p:sp>
+        <p:nvSpPr>
+          <p:cNvPr id="52" name="Rectangle 51"/>
+          <p:cNvSpPr/>
+          <p:nvPr/>
+        </p:nvSpPr>
+        <p:spPr>
+          <a:xfrm>
+            <a:off x="731520" y="4974336"/>
+            <a:ext cx="2560320" cy="237744"/>
+          </a:xfrm>
+          <a:prstGeom prst="rect">
+            <a:avLst/>
+          </a:prstGeom>
+          <a:solidFill>
+            <a:srgbClr val="1A1A2E"/>
+          </a:solidFill>
+          <a:ln w="12700">
+            <a:solidFill>
+              <a:srgbClr val="2A2A3E"/>
+            </a:solidFill>
+          </a:ln>
+        </p:spPr>
+        <p:style>
+          <a:lnRef idx="1">
+            <a:schemeClr val="accent1"/>
+          </a:lnRef>
+          <a:fillRef idx="3">
+            <a:schemeClr val="accent1"/>
+          </a:fillRef>
+          <a:effectRef idx="2">
+            <a:schemeClr val="accent1"/>
+          </a:effectRef>
+          <a:fontRef idx="minor">
+            <a:schemeClr val="lt1"/>
+          </a:fontRef>
+        </p:style>
+        <p:txBody>
+          <a:bodyPr rtlCol="0" anchor="ctr"/>
+          <a:lstStyle/>
+          <a:p>
+            <a:pPr algn="ctr">
+              <a:defRPr sz="700" b="0">
+                <a:solidFill>
+                  <a:srgbClr val="FBBF24"/>
+                </a:solidFill>
+                <a:latin typeface="Calibri"/>
+              </a:defRPr>
+            </a:pPr>
+            <a:r>
+              <a:t>Advertising</a:t>
+            </a:r>
+          </a:p>
+        </p:txBody>
+      </p:sp>
+      <p:sp>
+        <p:nvSpPr>
+          <p:cNvPr id="53" name="Rectangle 52"/>
+          <p:cNvSpPr/>
+          <p:nvPr/>
+        </p:nvSpPr>
+        <p:spPr>
+          <a:xfrm>
+            <a:off x="3291840" y="4974336"/>
+            <a:ext cx="1828800" cy="237744"/>
+          </a:xfrm>
+          <a:prstGeom prst="rect">
+            <a:avLst/>
+          </a:prstGeom>
+          <a:solidFill>
+            <a:srgbClr val="1A1A2E"/>
+          </a:solidFill>
+          <a:ln w="12700">
+            <a:solidFill>
+              <a:srgbClr val="2A2A3E"/>
+            </a:solidFill>
+          </a:ln>
+        </p:spPr>
+        <p:style>
+          <a:lnRef idx="1">
+            <a:schemeClr val="accent1"/>
+          </a:lnRef>
+          <a:fillRef idx="3">
+            <a:schemeClr val="accent1"/>
+          </a:fillRef>
+          <a:effectRef idx="2">
+            <a:schemeClr val="accent1"/>
+          </a:effectRef>
+          <a:fontRef idx="minor">
+            <a:schemeClr val="lt1"/>
+          </a:fontRef>
+        </p:style>
+        <p:txBody>
+          <a:bodyPr rtlCol="0" anchor="ctr"/>
+          <a:lstStyle/>
+          <a:p>
+            <a:pPr algn="ctr">
+              <a:defRPr sz="700" b="0">
+                <a:solidFill>
+                  <a:srgbClr val="FBBF24"/>
+                </a:solidFill>
+                <a:latin typeface="Calibri"/>
+              </a:defRPr>
+            </a:pPr>
+            <a:r>
+              <a:t>Rs.1L</a:t>
+            </a:r>
+          </a:p>
+        </p:txBody>
+      </p:sp>
+      <p:sp>
+        <p:nvSpPr>
+          <p:cNvPr id="54" name="Rectangle 53"/>
+          <p:cNvSpPr/>
+          <p:nvPr/>
+        </p:nvSpPr>
+        <p:spPr>
+          <a:xfrm>
+            <a:off x="5120640" y="4974336"/>
+            <a:ext cx="1828800" cy="237744"/>
+          </a:xfrm>
+          <a:prstGeom prst="rect">
+            <a:avLst/>
+          </a:prstGeom>
+          <a:solidFill>
+            <a:srgbClr val="1A1A2E"/>
+          </a:solidFill>
+          <a:ln w="12700">
+            <a:solidFill>
+              <a:srgbClr val="2A2A3E"/>
+            </a:solidFill>
+          </a:ln>
+        </p:spPr>
+        <p:style>
+          <a:lnRef idx="1">
+            <a:schemeClr val="accent1"/>
+          </a:lnRef>
+          <a:fillRef idx="3">
+            <a:schemeClr val="accent1"/>
+          </a:fillRef>
+          <a:effectRef idx="2">
+            <a:schemeClr val="accent1"/>
+          </a:effectRef>
+          <a:fontRef idx="minor">
+            <a:schemeClr val="lt1"/>
+          </a:fontRef>
+        </p:style>
+        <p:txBody>
+          <a:bodyPr rtlCol="0" anchor="ctr"/>
+          <a:lstStyle/>
+          <a:p>
+            <a:pPr algn="ctr">
+              <a:defRPr sz="700" b="0">
+                <a:solidFill>
+                  <a:srgbClr val="FBBF24"/>
+                </a:solidFill>
+                <a:latin typeface="Calibri"/>
+              </a:defRPr>
+            </a:pPr>
+            <a:r>
+              <a:t>Rs.5L</a:t>
+            </a:r>
+          </a:p>
+        </p:txBody>
+      </p:sp>
+      <p:sp>
+        <p:nvSpPr>
+          <p:cNvPr id="55" name="Rectangle 54"/>
+          <p:cNvSpPr/>
+          <p:nvPr/>
+        </p:nvSpPr>
+        <p:spPr>
+          <a:xfrm>
+            <a:off x="6949440" y="4974336"/>
+            <a:ext cx="1828800" cy="237744"/>
+          </a:xfrm>
+          <a:prstGeom prst="rect">
+            <a:avLst/>
+          </a:prstGeom>
+          <a:solidFill>
+            <a:srgbClr val="1A1A2E"/>
+          </a:solidFill>
+          <a:ln w="12700">
+            <a:solidFill>
+              <a:srgbClr val="2A2A3E"/>
+            </a:solidFill>
+          </a:ln>
+        </p:spPr>
+        <p:style>
+          <a:lnRef idx="1">
+            <a:schemeClr val="accent1"/>
+          </a:lnRef>
+          <a:fillRef idx="3">
+            <a:schemeClr val="accent1"/>
+          </a:fillRef>
+          <a:effectRef idx="2">
+            <a:schemeClr val="accent1"/>
+          </a:effectRef>
+          <a:fontRef idx="minor">
+            <a:schemeClr val="lt1"/>
+          </a:fontRef>
+        </p:style>
+        <p:txBody>
+          <a:bodyPr rtlCol="0" anchor="ctr"/>
+          <a:lstStyle/>
+          <a:p>
+            <a:pPr algn="ctr">
+              <a:defRPr sz="700" b="0">
+                <a:solidFill>
+                  <a:srgbClr val="FBBF24"/>
+                </a:solidFill>
+                <a:latin typeface="Calibri"/>
+              </a:defRPr>
+            </a:pPr>
+            <a:r>
+              <a:t>Rs.15L</a:t>
+            </a:r>
+          </a:p>
+        </p:txBody>
+      </p:sp>
+      <p:sp>
+        <p:nvSpPr>
+          <p:cNvPr id="56" name="Rectangle 55"/>
+          <p:cNvSpPr/>
+          <p:nvPr/>
+        </p:nvSpPr>
+        <p:spPr>
+          <a:xfrm>
+            <a:off x="731520" y="5212080"/>
+            <a:ext cx="2560320" cy="237744"/>
+          </a:xfrm>
+          <a:prstGeom prst="rect">
+            <a:avLst/>
+          </a:prstGeom>
+          <a:solidFill>
+            <a:srgbClr val="2A2A4A"/>
+          </a:solidFill>
+          <a:ln w="12700">
+            <a:solidFill>
+              <a:srgbClr val="2A2A3E"/>
+            </a:solidFill>
+          </a:ln>
+        </p:spPr>
+        <p:style>
+          <a:lnRef idx="1">
+            <a:schemeClr val="accent1"/>
+          </a:lnRef>
+          <a:fillRef idx="3">
+            <a:schemeClr val="accent1"/>
+          </a:fillRef>
+          <a:effectRef idx="2">
+            <a:schemeClr val="accent1"/>
+          </a:effectRef>
+          <a:fontRef idx="minor">
+            <a:schemeClr val="lt1"/>
+          </a:fontRef>
+        </p:style>
+        <p:txBody>
+          <a:bodyPr rtlCol="0" anchor="ctr"/>
+          <a:lstStyle/>
+          <a:p>
+            <a:pPr algn="ctr">
+              <a:defRPr sz="700" b="1">
+                <a:solidFill>
+                  <a:srgbClr val="34D399"/>
+                </a:solidFill>
+                <a:latin typeface="Calibri"/>
+              </a:defRPr>
+            </a:pPr>
+            <a:r>
+              <a:t>Total Revenue</a:t>
+            </a:r>
+          </a:p>
+        </p:txBody>
+      </p:sp>
+      <p:sp>
+        <p:nvSpPr>
+          <p:cNvPr id="57" name="Rectangle 56"/>
+          <p:cNvSpPr/>
+          <p:nvPr/>
+        </p:nvSpPr>
+        <p:spPr>
+          <a:xfrm>
+            <a:off x="3291840" y="5212080"/>
+            <a:ext cx="1828800" cy="237744"/>
+          </a:xfrm>
+          <a:prstGeom prst="rect">
+            <a:avLst/>
+          </a:prstGeom>
+          <a:solidFill>
+            <a:srgbClr val="2A2A4A"/>
+          </a:solidFill>
+          <a:ln w="12700">
+            <a:solidFill>
+              <a:srgbClr val="2A2A3E"/>
+            </a:solidFill>
+          </a:ln>
+        </p:spPr>
+        <p:style>
+          <a:lnRef idx="1">
+            <a:schemeClr val="accent1"/>
+          </a:lnRef>
+          <a:fillRef idx="3">
+            <a:schemeClr val="accent1"/>
+          </a:fillRef>
+          <a:effectRef idx="2">
+            <a:schemeClr val="accent1"/>
+          </a:effectRef>
+          <a:fontRef idx="minor">
+            <a:schemeClr val="lt1"/>
+          </a:fontRef>
+        </p:style>
+        <p:txBody>
+          <a:bodyPr rtlCol="0" anchor="ctr"/>
+          <a:lstStyle/>
+          <a:p>
+            <a:pPr algn="ctr">
+              <a:defRPr sz="700" b="1">
+                <a:solidFill>
+                  <a:srgbClr val="34D399"/>
+                </a:solidFill>
+                <a:latin typeface="Calibri"/>
+              </a:defRPr>
+            </a:pPr>
+            <a:r>
+              <a:t>Rs.12.9L</a:t>
+            </a:r>
+          </a:p>
+        </p:txBody>
+      </p:sp>
+      <p:sp>
+        <p:nvSpPr>
+          <p:cNvPr id="58" name="Rectangle 57"/>
+          <p:cNvSpPr/>
+          <p:nvPr/>
+        </p:nvSpPr>
+        <p:spPr>
+          <a:xfrm>
+            <a:off x="5120640" y="5212080"/>
+            <a:ext cx="1828800" cy="237744"/>
+          </a:xfrm>
+          <a:prstGeom prst="rect">
+            <a:avLst/>
+          </a:prstGeom>
+          <a:solidFill>
+            <a:srgbClr val="2A2A4A"/>
+          </a:solidFill>
+          <a:ln w="12700">
+            <a:solidFill>
+              <a:srgbClr val="2A2A3E"/>
+            </a:solidFill>
+          </a:ln>
+        </p:spPr>
+        <p:style>
+          <a:lnRef idx="1">
+            <a:schemeClr val="accent1"/>
+          </a:lnRef>
+          <a:fillRef idx="3">
+            <a:schemeClr val="accent1"/>
+          </a:fillRef>
+          <a:effectRef idx="2">
+            <a:schemeClr val="accent1"/>
+          </a:effectRef>
+          <a:fontRef idx="minor">
+            <a:schemeClr val="lt1"/>
+          </a:fontRef>
+        </p:style>
+        <p:txBody>
+          <a:bodyPr rtlCol="0" anchor="ctr"/>
+          <a:lstStyle/>
+          <a:p>
+            <a:pPr algn="ctr">
+              <a:defRPr sz="700" b="1">
+                <a:solidFill>
+                  <a:srgbClr val="34D399"/>
+                </a:solidFill>
+                <a:latin typeface="Calibri"/>
+              </a:defRPr>
+            </a:pPr>
+            <a:r>
+              <a:t>Rs.1.02Cr</a:t>
+            </a:r>
+          </a:p>
+        </p:txBody>
+      </p:sp>
+      <p:sp>
+        <p:nvSpPr>
+          <p:cNvPr id="59" name="Rectangle 58"/>
+          <p:cNvSpPr/>
+          <p:nvPr/>
+        </p:nvSpPr>
+        <p:spPr>
+          <a:xfrm>
+            <a:off x="6949440" y="5212080"/>
+            <a:ext cx="1828800" cy="237744"/>
+          </a:xfrm>
+          <a:prstGeom prst="rect">
+            <a:avLst/>
+          </a:prstGeom>
+          <a:solidFill>
+            <a:srgbClr val="2A2A4A"/>
+          </a:solidFill>
+          <a:ln w="12700">
+            <a:solidFill>
+              <a:srgbClr val="2A2A3E"/>
+            </a:solidFill>
+          </a:ln>
+        </p:spPr>
+        <p:style>
+          <a:lnRef idx="1">
+            <a:schemeClr val="accent1"/>
+          </a:lnRef>
+          <a:fillRef idx="3">
+            <a:schemeClr val="accent1"/>
+          </a:fillRef>
+          <a:effectRef idx="2">
+            <a:schemeClr val="accent1"/>
+          </a:effectRef>
+          <a:fontRef idx="minor">
+            <a:schemeClr val="lt1"/>
+          </a:fontRef>
+        </p:style>
+        <p:txBody>
+          <a:bodyPr rtlCol="0" anchor="ctr"/>
+          <a:lstStyle/>
+          <a:p>
+            <a:pPr algn="ctr">
+              <a:defRPr sz="700" b="1">
+                <a:solidFill>
+                  <a:srgbClr val="34D399"/>
+                </a:solidFill>
+                <a:latin typeface="Calibri"/>
+              </a:defRPr>
+            </a:pPr>
+            <a:r>
+              <a:t>Rs.7.14Cr</a:t>
+            </a:r>
+          </a:p>
+        </p:txBody>
+      </p:sp>
+      <p:sp>
+        <p:nvSpPr>
+          <p:cNvPr id="60" name="TextBox 59"/>
+          <p:cNvSpPr txBox="1"/>
+          <p:nvPr/>
+        </p:nvSpPr>
+        <p:spPr>
+          <a:xfrm>
+            <a:off x="6858000" y="2834640"/>
+            <a:ext cx="5029200" cy="228600"/>
+          </a:xfrm>
+          <a:prstGeom prst="rect">
+            <a:avLst/>
+          </a:prstGeom>
+          <a:noFill/>
+        </p:spPr>
+        <p:txBody>
+          <a:bodyPr wrap="square">
+            <a:spAutoFit/>
+          </a:bodyPr>
+          <a:lstStyle/>
+          <a:p>
+            <a:pPr algn="l">
+              <a:defRPr sz="1100" b="1">
+                <a:solidFill>
+                  <a:srgbClr val="A78BFA"/>
+                </a:solidFill>
+                <a:latin typeface="Calibri"/>
+              </a:defRPr>
+            </a:pPr>
+            <a:r>
+              <a:t>Monthly Revenue Stages</a:t>
+            </a:r>
+          </a:p>
+        </p:txBody>
+      </p:sp>
+      <p:sp>
+        <p:nvSpPr>
+          <p:cNvPr id="61" name="Rectangle 60"/>
+          <p:cNvSpPr/>
+          <p:nvPr/>
+        </p:nvSpPr>
+        <p:spPr>
+          <a:xfrm>
+            <a:off x="6858000" y="3063240"/>
+            <a:ext cx="1645920" cy="201168"/>
+          </a:xfrm>
+          <a:prstGeom prst="rect">
+            <a:avLst/>
+          </a:prstGeom>
+          <a:solidFill>
+            <a:srgbClr val="A78BFA"/>
+          </a:solidFill>
+          <a:ln>
+            <a:noFill/>
+          </a:ln>
+        </p:spPr>
+        <p:style>
+          <a:lnRef idx="1">
+            <a:schemeClr val="accent1"/>
+          </a:lnRef>
+          <a:fillRef idx="3">
+            <a:schemeClr val="accent1"/>
+          </a:fillRef>
+          <a:effectRef idx="2">
+            <a:schemeClr val="accent1"/>
+          </a:effectRef>
+          <a:fontRef idx="minor">
+            <a:schemeClr val="lt1"/>
+          </a:fontRef>
+        </p:style>
+        <p:txBody>
+          <a:bodyPr rtlCol="0" anchor="ctr"/>
+          <a:lstStyle/>
+          <a:p>
+            <a:pPr algn="ctr">
+              <a:defRPr sz="700" b="1">
+                <a:solidFill>
+                  <a:srgbClr val="FFFFFF"/>
+                </a:solidFill>
+                <a:latin typeface="Calibri"/>
+              </a:defRPr>
+            </a:pPr>
+            <a:r>
+              <a:t>Stage</a:t>
+            </a:r>
+          </a:p>
+        </p:txBody>
+      </p:sp>
+      <p:sp>
+        <p:nvSpPr>
+          <p:cNvPr id="62" name="Rectangle 61"/>
+          <p:cNvSpPr/>
+          <p:nvPr/>
+        </p:nvSpPr>
+        <p:spPr>
+          <a:xfrm>
+            <a:off x="8503920" y="3063240"/>
+            <a:ext cx="1097280" cy="201168"/>
+          </a:xfrm>
+          <a:prstGeom prst="rect">
+            <a:avLst/>
+          </a:prstGeom>
+          <a:solidFill>
+            <a:srgbClr val="A78BFA"/>
+          </a:solidFill>
+          <a:ln>
+            <a:noFill/>
+          </a:ln>
+        </p:spPr>
+        <p:style>
+          <a:lnRef idx="1">
+            <a:schemeClr val="accent1"/>
+          </a:lnRef>
+          <a:fillRef idx="3">
+            <a:schemeClr val="accent1"/>
+          </a:fillRef>
+          <a:effectRef idx="2">
+            <a:schemeClr val="accent1"/>
+          </a:effectRef>
+          <a:fontRef idx="minor">
+            <a:schemeClr val="lt1"/>
+          </a:fontRef>
+        </p:style>
+        <p:txBody>
+          <a:bodyPr rtlCol="0" anchor="ctr"/>
+          <a:lstStyle/>
+          <a:p>
+            <a:pPr algn="ctr">
+              <a:defRPr sz="700" b="1">
+                <a:solidFill>
+                  <a:srgbClr val="FFFFFF"/>
+                </a:solidFill>
+                <a:latin typeface="Calibri"/>
+              </a:defRPr>
+            </a:pPr>
+            <a:r>
+              <a:t>Users</a:t>
+            </a:r>
+          </a:p>
+        </p:txBody>
+      </p:sp>
+      <p:sp>
+        <p:nvSpPr>
+          <p:cNvPr id="63" name="Rectangle 62"/>
+          <p:cNvSpPr/>
+          <p:nvPr/>
+        </p:nvSpPr>
+        <p:spPr>
+          <a:xfrm>
+            <a:off x="9601200" y="3063240"/>
+            <a:ext cx="1371600" cy="201168"/>
+          </a:xfrm>
+          <a:prstGeom prst="rect">
+            <a:avLst/>
+          </a:prstGeom>
+          <a:solidFill>
+            <a:srgbClr val="A78BFA"/>
+          </a:solidFill>
+          <a:ln>
+            <a:noFill/>
+          </a:ln>
+        </p:spPr>
+        <p:style>
+          <a:lnRef idx="1">
+            <a:schemeClr val="accent1"/>
+          </a:lnRef>
+          <a:fillRef idx="3">
+            <a:schemeClr val="accent1"/>
+          </a:fillRef>
+          <a:effectRef idx="2">
+            <a:schemeClr val="accent1"/>
+          </a:effectRef>
+          <a:fontRef idx="minor">
+            <a:schemeClr val="lt1"/>
+          </a:fontRef>
+        </p:style>
+        <p:txBody>
+          <a:bodyPr rtlCol="0" anchor="ctr"/>
+          <a:lstStyle/>
+          <a:p>
+            <a:pPr algn="ctr">
+              <a:defRPr sz="700" b="1">
+                <a:solidFill>
+                  <a:srgbClr val="FFFFFF"/>
+                </a:solidFill>
+                <a:latin typeface="Calibri"/>
+              </a:defRPr>
+            </a:pPr>
+            <a:r>
+              <a:t>MRR</a:t>
+            </a:r>
+          </a:p>
+        </p:txBody>
+      </p:sp>
+      <p:sp>
+        <p:nvSpPr>
+          <p:cNvPr id="64" name="Rectangle 63"/>
+          <p:cNvSpPr/>
+          <p:nvPr/>
+        </p:nvSpPr>
+        <p:spPr>
+          <a:xfrm>
+            <a:off x="6858000" y="3264408"/>
+            <a:ext cx="1645920" cy="201168"/>
+          </a:xfrm>
+          <a:prstGeom prst="rect">
+            <a:avLst/>
+          </a:prstGeom>
+          <a:solidFill>
+            <a:srgbClr val="1A1A2E"/>
+          </a:solidFill>
+          <a:ln w="12700">
+            <a:solidFill>
+              <a:srgbClr val="2A2A3E"/>
+            </a:solidFill>
+          </a:ln>
+        </p:spPr>
+        <p:style>
+          <a:lnRef idx="1">
+            <a:schemeClr val="accent1"/>
+          </a:lnRef>
+          <a:fillRef idx="3">
+            <a:schemeClr val="accent1"/>
+          </a:fillRef>
+          <a:effectRef idx="2">
+            <a:schemeClr val="accent1"/>
+          </a:effectRef>
+          <a:fontRef idx="minor">
+            <a:schemeClr val="lt1"/>
+          </a:fontRef>
+        </p:style>
+        <p:txBody>
+          <a:bodyPr rtlCol="0" anchor="ctr"/>
+          <a:lstStyle/>
+          <a:p>
+            <a:pPr algn="ctr">
+              <a:defRPr sz="700" b="0">
+                <a:solidFill>
+                  <a:srgbClr val="CCCCCC"/>
+                </a:solidFill>
+                <a:latin typeface="Calibri"/>
+              </a:defRPr>
+            </a:pPr>
+            <a:r>
+              <a:t>MVP Launch</a:t>
+            </a:r>
+          </a:p>
+        </p:txBody>
+      </p:sp>
+      <p:sp>
+        <p:nvSpPr>
+          <p:cNvPr id="65" name="Rectangle 64"/>
+          <p:cNvSpPr/>
+          <p:nvPr/>
+        </p:nvSpPr>
+        <p:spPr>
+          <a:xfrm>
+            <a:off x="8503920" y="3264408"/>
+            <a:ext cx="1097280" cy="201168"/>
+          </a:xfrm>
+          <a:prstGeom prst="rect">
+            <a:avLst/>
+          </a:prstGeom>
+          <a:solidFill>
+            <a:srgbClr val="1A1A2E"/>
+          </a:solidFill>
+          <a:ln w="12700">
+            <a:solidFill>
+              <a:srgbClr val="2A2A3E"/>
+            </a:solidFill>
+          </a:ln>
+        </p:spPr>
+        <p:style>
+          <a:lnRef idx="1">
+            <a:schemeClr val="accent1"/>
+          </a:lnRef>
+          <a:fillRef idx="3">
+            <a:schemeClr val="accent1"/>
+          </a:fillRef>
+          <a:effectRef idx="2">
+            <a:schemeClr val="accent1"/>
+          </a:effectRef>
+          <a:fontRef idx="minor">
+            <a:schemeClr val="lt1"/>
+          </a:fontRef>
+        </p:style>
+        <p:txBody>
+          <a:bodyPr rtlCol="0" anchor="ctr"/>
+          <a:lstStyle/>
+          <a:p>
+            <a:pPr algn="ctr">
+              <a:defRPr sz="700" b="0">
+                <a:solidFill>
+                  <a:srgbClr val="CCCCCC"/>
+                </a:solidFill>
+                <a:latin typeface="Calibri"/>
+              </a:defRPr>
+            </a:pPr>
+            <a:r>
+              <a:t>100</a:t>
+            </a:r>
+          </a:p>
+        </p:txBody>
+      </p:sp>
+      <p:sp>
+        <p:nvSpPr>
+          <p:cNvPr id="66" name="Rectangle 65"/>
+          <p:cNvSpPr/>
+          <p:nvPr/>
+        </p:nvSpPr>
+        <p:spPr>
+          <a:xfrm>
+            <a:off x="9601200" y="3264408"/>
+            <a:ext cx="1371600" cy="201168"/>
+          </a:xfrm>
+          <a:prstGeom prst="rect">
+            <a:avLst/>
+          </a:prstGeom>
+          <a:solidFill>
+            <a:srgbClr val="1A1A2E"/>
+          </a:solidFill>
+          <a:ln w="12700">
+            <a:solidFill>
+              <a:srgbClr val="2A2A3E"/>
+            </a:solidFill>
+          </a:ln>
+        </p:spPr>
+        <p:style>
+          <a:lnRef idx="1">
+            <a:schemeClr val="accent1"/>
+          </a:lnRef>
+          <a:fillRef idx="3">
+            <a:schemeClr val="accent1"/>
+          </a:fillRef>
+          <a:effectRef idx="2">
+            <a:schemeClr val="accent1"/>
+          </a:effectRef>
+          <a:fontRef idx="minor">
+            <a:schemeClr val="lt1"/>
+          </a:fontRef>
+        </p:style>
+        <p:txBody>
+          <a:bodyPr rtlCol="0" anchor="ctr"/>
+          <a:lstStyle/>
+          <a:p>
+            <a:pPr algn="ctr">
+              <a:defRPr sz="700" b="1">
+                <a:solidFill>
+                  <a:srgbClr val="34D399"/>
+                </a:solidFill>
+                <a:latin typeface="Calibri"/>
+              </a:defRPr>
+            </a:pPr>
+            <a:r>
+              <a:t>Rs.19.9K</a:t>
+            </a:r>
+          </a:p>
+        </p:txBody>
+      </p:sp>
+      <p:sp>
+        <p:nvSpPr>
+          <p:cNvPr id="67" name="Rectangle 66"/>
+          <p:cNvSpPr/>
+          <p:nvPr/>
+        </p:nvSpPr>
+        <p:spPr>
+          <a:xfrm>
+            <a:off x="6858000" y="3465576"/>
+            <a:ext cx="1645920" cy="201168"/>
+          </a:xfrm>
+          <a:prstGeom prst="rect">
+            <a:avLst/>
+          </a:prstGeom>
+          <a:solidFill>
+            <a:srgbClr val="151528"/>
+          </a:solidFill>
+          <a:ln w="12700">
+            <a:solidFill>
+              <a:srgbClr val="2A2A3E"/>
+            </a:solidFill>
+          </a:ln>
+        </p:spPr>
+        <p:style>
+          <a:lnRef idx="1">
+            <a:schemeClr val="accent1"/>
+          </a:lnRef>
+          <a:fillRef idx="3">
+            <a:schemeClr val="accent1"/>
+          </a:fillRef>
+          <a:effectRef idx="2">
+            <a:schemeClr val="accent1"/>
+          </a:effectRef>
+          <a:fontRef idx="minor">
+            <a:schemeClr val="lt1"/>
+          </a:fontRef>
+        </p:style>
+        <p:txBody>
+          <a:bodyPr rtlCol="0" anchor="ctr"/>
+          <a:lstStyle/>
+          <a:p>
+            <a:pPr algn="ctr">
+              <a:defRPr sz="700" b="0">
+                <a:solidFill>
+                  <a:srgbClr val="CCCCCC"/>
+                </a:solidFill>
+                <a:latin typeface="Calibri"/>
+              </a:defRPr>
+            </a:pPr>
+            <a:r>
+              <a:t>Milestone</a:t>
+            </a:r>
+          </a:p>
+        </p:txBody>
+      </p:sp>
+      <p:sp>
+        <p:nvSpPr>
+          <p:cNvPr id="68" name="Rectangle 67"/>
+          <p:cNvSpPr/>
+          <p:nvPr/>
+        </p:nvSpPr>
+        <p:spPr>
+          <a:xfrm>
+            <a:off x="8503920" y="3465576"/>
+            <a:ext cx="1097280" cy="201168"/>
+          </a:xfrm>
+          <a:prstGeom prst="rect">
+            <a:avLst/>
+          </a:prstGeom>
+          <a:solidFill>
+            <a:srgbClr val="151528"/>
+          </a:solidFill>
+          <a:ln w="12700">
+            <a:solidFill>
+              <a:srgbClr val="2A2A3E"/>
+            </a:solidFill>
+          </a:ln>
+        </p:spPr>
+        <p:style>
+          <a:lnRef idx="1">
+            <a:schemeClr val="accent1"/>
+          </a:lnRef>
+          <a:fillRef idx="3">
+            <a:schemeClr val="accent1"/>
+          </a:fillRef>
+          <a:effectRef idx="2">
+            <a:schemeClr val="accent1"/>
+          </a:effectRef>
+          <a:fontRef idx="minor">
+            <a:schemeClr val="lt1"/>
+          </a:fontRef>
+        </p:style>
+        <p:txBody>
+          <a:bodyPr rtlCol="0" anchor="ctr"/>
+          <a:lstStyle/>
+          <a:p>
+            <a:pPr algn="ctr">
+              <a:defRPr sz="700" b="0">
+                <a:solidFill>
+                  <a:srgbClr val="CCCCCC"/>
+                </a:solidFill>
+                <a:latin typeface="Calibri"/>
+              </a:defRPr>
+            </a:pPr>
+            <a:r>
+              <a:t>500</a:t>
+            </a:r>
+          </a:p>
+        </p:txBody>
+      </p:sp>
+      <p:sp>
+        <p:nvSpPr>
+          <p:cNvPr id="69" name="Rectangle 68"/>
+          <p:cNvSpPr/>
+          <p:nvPr/>
+        </p:nvSpPr>
+        <p:spPr>
+          <a:xfrm>
+            <a:off x="9601200" y="3465576"/>
+            <a:ext cx="1371600" cy="201168"/>
+          </a:xfrm>
+          <a:prstGeom prst="rect">
+            <a:avLst/>
+          </a:prstGeom>
+          <a:solidFill>
+            <a:srgbClr val="151528"/>
+          </a:solidFill>
+          <a:ln w="12700">
+            <a:solidFill>
+              <a:srgbClr val="2A2A3E"/>
+            </a:solidFill>
+          </a:ln>
+        </p:spPr>
+        <p:style>
+          <a:lnRef idx="1">
+            <a:schemeClr val="accent1"/>
+          </a:lnRef>
+          <a:fillRef idx="3">
+            <a:schemeClr val="accent1"/>
+          </a:fillRef>
+          <a:effectRef idx="2">
+            <a:schemeClr val="accent1"/>
+          </a:effectRef>
+          <a:fontRef idx="minor">
+            <a:schemeClr val="lt1"/>
+          </a:fontRef>
+        </p:style>
+        <p:txBody>
+          <a:bodyPr rtlCol="0" anchor="ctr"/>
+          <a:lstStyle/>
+          <a:p>
+            <a:pPr algn="ctr">
+              <a:defRPr sz="700" b="1">
+                <a:solidFill>
+                  <a:srgbClr val="34D399"/>
+                </a:solidFill>
+                <a:latin typeface="Calibri"/>
+              </a:defRPr>
+            </a:pPr>
+            <a:r>
+              <a:t>Rs.99.5K</a:t>
+            </a:r>
+          </a:p>
+        </p:txBody>
+      </p:sp>
+      <p:sp>
+        <p:nvSpPr>
+          <p:cNvPr id="70" name="Rectangle 69"/>
+          <p:cNvSpPr/>
+          <p:nvPr/>
+        </p:nvSpPr>
+        <p:spPr>
+          <a:xfrm>
+            <a:off x="6858000" y="3666744"/>
+            <a:ext cx="1645920" cy="201168"/>
+          </a:xfrm>
+          <a:prstGeom prst="rect">
+            <a:avLst/>
+          </a:prstGeom>
+          <a:solidFill>
+            <a:srgbClr val="1A1A2E"/>
+          </a:solidFill>
+          <a:ln w="12700">
+            <a:solidFill>
+              <a:srgbClr val="2A2A3E"/>
+            </a:solidFill>
+          </a:ln>
+        </p:spPr>
+        <p:style>
+          <a:lnRef idx="1">
+            <a:schemeClr val="accent1"/>
+          </a:lnRef>
+          <a:fillRef idx="3">
+            <a:schemeClr val="accent1"/>
+          </a:fillRef>
+          <a:effectRef idx="2">
+            <a:schemeClr val="accent1"/>
+          </a:effectRef>
+          <a:fontRef idx="minor">
+            <a:schemeClr val="lt1"/>
+          </a:fontRef>
+        </p:style>
+        <p:txBody>
+          <a:bodyPr rtlCol="0" anchor="ctr"/>
+          <a:lstStyle/>
+          <a:p>
+            <a:pPr algn="ctr">
+              <a:defRPr sz="700" b="0">
+                <a:solidFill>
+                  <a:srgbClr val="CCCCCC"/>
+                </a:solidFill>
+                <a:latin typeface="Calibri"/>
+              </a:defRPr>
+            </a:pPr>
+            <a:r>
+              <a:t>PM-Fit</a:t>
+            </a:r>
+          </a:p>
+        </p:txBody>
+      </p:sp>
+      <p:sp>
+        <p:nvSpPr>
+          <p:cNvPr id="71" name="Rectangle 70"/>
+          <p:cNvSpPr/>
+          <p:nvPr/>
+        </p:nvSpPr>
+        <p:spPr>
+          <a:xfrm>
+            <a:off x="8503920" y="3666744"/>
+            <a:ext cx="1097280" cy="201168"/>
+          </a:xfrm>
+          <a:prstGeom prst="rect">
+            <a:avLst/>
+          </a:prstGeom>
+          <a:solidFill>
+            <a:srgbClr val="1A1A2E"/>
+          </a:solidFill>
+          <a:ln w="12700">
+            <a:solidFill>
+              <a:srgbClr val="2A2A3E"/>
+            </a:solidFill>
+          </a:ln>
+        </p:spPr>
+        <p:style>
+          <a:lnRef idx="1">
+            <a:schemeClr val="accent1"/>
+          </a:lnRef>
+          <a:fillRef idx="3">
+            <a:schemeClr val="accent1"/>
+          </a:fillRef>
+          <a:effectRef idx="2">
+            <a:schemeClr val="accent1"/>
+          </a:effectRef>
+          <a:fontRef idx="minor">
+            <a:schemeClr val="lt1"/>
+          </a:fontRef>
+        </p:style>
+        <p:txBody>
+          <a:bodyPr rtlCol="0" anchor="ctr"/>
+          <a:lstStyle/>
+          <a:p>
+            <a:pPr algn="ctr">
+              <a:defRPr sz="700" b="0">
+                <a:solidFill>
+                  <a:srgbClr val="CCCCCC"/>
+                </a:solidFill>
+                <a:latin typeface="Calibri"/>
+              </a:defRPr>
+            </a:pPr>
+            <a:r>
+              <a:t>2,500</a:t>
+            </a:r>
+          </a:p>
+        </p:txBody>
+      </p:sp>
+      <p:sp>
+        <p:nvSpPr>
+          <p:cNvPr id="72" name="Rectangle 71"/>
+          <p:cNvSpPr/>
+          <p:nvPr/>
+        </p:nvSpPr>
+        <p:spPr>
+          <a:xfrm>
+            <a:off x="9601200" y="3666744"/>
+            <a:ext cx="1371600" cy="201168"/>
+          </a:xfrm>
+          <a:prstGeom prst="rect">
+            <a:avLst/>
+          </a:prstGeom>
+          <a:solidFill>
+            <a:srgbClr val="1A1A2E"/>
+          </a:solidFill>
+          <a:ln w="12700">
+            <a:solidFill>
+              <a:srgbClr val="2A2A3E"/>
+            </a:solidFill>
+          </a:ln>
+        </p:spPr>
+        <p:style>
+          <a:lnRef idx="1">
+            <a:schemeClr val="accent1"/>
+          </a:lnRef>
+          <a:fillRef idx="3">
+            <a:schemeClr val="accent1"/>
+          </a:fillRef>
+          <a:effectRef idx="2">
+            <a:schemeClr val="accent1"/>
+          </a:effectRef>
+          <a:fontRef idx="minor">
+            <a:schemeClr val="lt1"/>
+          </a:fontRef>
+        </p:style>
+        <p:txBody>
+          <a:bodyPr rtlCol="0" anchor="ctr"/>
+          <a:lstStyle/>
+          <a:p>
+            <a:pPr algn="ctr">
+              <a:defRPr sz="700" b="1">
+                <a:solidFill>
+                  <a:srgbClr val="34D399"/>
+                </a:solidFill>
+                <a:latin typeface="Calibri"/>
+              </a:defRPr>
+            </a:pPr>
+            <a:r>
+              <a:t>Rs.6.2L</a:t>
+            </a:r>
+          </a:p>
+        </p:txBody>
+      </p:sp>
+      <p:sp>
+        <p:nvSpPr>
+          <p:cNvPr id="73" name="Rectangle 72"/>
+          <p:cNvSpPr/>
+          <p:nvPr/>
+        </p:nvSpPr>
+        <p:spPr>
+          <a:xfrm>
+            <a:off x="6858000" y="3867912"/>
+            <a:ext cx="1645920" cy="201168"/>
+          </a:xfrm>
+          <a:prstGeom prst="rect">
+            <a:avLst/>
+          </a:prstGeom>
+          <a:solidFill>
+            <a:srgbClr val="151528"/>
+          </a:solidFill>
+          <a:ln w="12700">
+            <a:solidFill>
+              <a:srgbClr val="2A2A3E"/>
+            </a:solidFill>
+          </a:ln>
+        </p:spPr>
+        <p:style>
+          <a:lnRef idx="1">
+            <a:schemeClr val="accent1"/>
+          </a:lnRef>
+          <a:fillRef idx="3">
+            <a:schemeClr val="accent1"/>
+          </a:fillRef>
+          <a:effectRef idx="2">
+            <a:schemeClr val="accent1"/>
+          </a:effectRef>
+          <a:fontRef idx="minor">
+            <a:schemeClr val="lt1"/>
+          </a:fontRef>
+        </p:style>
+        <p:txBody>
+          <a:bodyPr rtlCol="0" anchor="ctr"/>
+          <a:lstStyle/>
+          <a:p>
+            <a:pPr algn="ctr">
+              <a:defRPr sz="700" b="0">
+                <a:solidFill>
+                  <a:srgbClr val="CCCCCC"/>
+                </a:solidFill>
+                <a:latin typeface="Calibri"/>
+              </a:defRPr>
+            </a:pPr>
+            <a:r>
+              <a:t>Growth</a:t>
+            </a:r>
+          </a:p>
+        </p:txBody>
+      </p:sp>
+      <p:sp>
+        <p:nvSpPr>
+          <p:cNvPr id="74" name="Rectangle 73"/>
+          <p:cNvSpPr/>
+          <p:nvPr/>
+        </p:nvSpPr>
+        <p:spPr>
+          <a:xfrm>
+            <a:off x="8503920" y="3867912"/>
+            <a:ext cx="1097280" cy="201168"/>
+          </a:xfrm>
+          <a:prstGeom prst="rect">
+            <a:avLst/>
+          </a:prstGeom>
+          <a:solidFill>
+            <a:srgbClr val="151528"/>
+          </a:solidFill>
+          <a:ln w="12700">
+            <a:solidFill>
+              <a:srgbClr val="2A2A3E"/>
+            </a:solidFill>
+          </a:ln>
+        </p:spPr>
+        <p:style>
+          <a:lnRef idx="1">
+            <a:schemeClr val="accent1"/>
+          </a:lnRef>
+          <a:fillRef idx="3">
+            <a:schemeClr val="accent1"/>
+          </a:fillRef>
+          <a:effectRef idx="2">
+            <a:schemeClr val="accent1"/>
+          </a:effectRef>
+          <a:fontRef idx="minor">
+            <a:schemeClr val="lt1"/>
+          </a:fontRef>
+        </p:style>
+        <p:txBody>
+          <a:bodyPr rtlCol="0" anchor="ctr"/>
+          <a:lstStyle/>
+          <a:p>
+            <a:pPr algn="ctr">
+              <a:defRPr sz="700" b="0">
+                <a:solidFill>
+                  <a:srgbClr val="CCCCCC"/>
+                </a:solidFill>
+                <a:latin typeface="Calibri"/>
+              </a:defRPr>
+            </a:pPr>
+            <a:r>
+              <a:t>5,000</a:t>
+            </a:r>
+          </a:p>
+        </p:txBody>
+      </p:sp>
+      <p:sp>
+        <p:nvSpPr>
+          <p:cNvPr id="75" name="Rectangle 74"/>
+          <p:cNvSpPr/>
+          <p:nvPr/>
+        </p:nvSpPr>
+        <p:spPr>
+          <a:xfrm>
+            <a:off x="9601200" y="3867912"/>
+            <a:ext cx="1371600" cy="201168"/>
+          </a:xfrm>
+          <a:prstGeom prst="rect">
+            <a:avLst/>
+          </a:prstGeom>
+          <a:solidFill>
+            <a:srgbClr val="151528"/>
+          </a:solidFill>
+          <a:ln w="12700">
+            <a:solidFill>
+              <a:srgbClr val="2A2A3E"/>
+            </a:solidFill>
+          </a:ln>
+        </p:spPr>
+        <p:style>
+          <a:lnRef idx="1">
+            <a:schemeClr val="accent1"/>
+          </a:lnRef>
+          <a:fillRef idx="3">
+            <a:schemeClr val="accent1"/>
+          </a:fillRef>
+          <a:effectRef idx="2">
+            <a:schemeClr val="accent1"/>
+          </a:effectRef>
+          <a:fontRef idx="minor">
+            <a:schemeClr val="lt1"/>
+          </a:fontRef>
+        </p:style>
+        <p:txBody>
+          <a:bodyPr rtlCol="0" anchor="ctr"/>
+          <a:lstStyle/>
+          <a:p>
+            <a:pPr algn="ctr">
+              <a:defRPr sz="700" b="1">
+                <a:solidFill>
+                  <a:srgbClr val="34D399"/>
+                </a:solidFill>
+                <a:latin typeface="Calibri"/>
+              </a:defRPr>
+            </a:pPr>
+            <a:r>
+              <a:t>Rs.12.4L</a:t>
+            </a:r>
+          </a:p>
+        </p:txBody>
+      </p:sp>
+      <p:sp>
+        <p:nvSpPr>
+          <p:cNvPr id="76" name="Rectangle 75"/>
+          <p:cNvSpPr/>
+          <p:nvPr/>
+        </p:nvSpPr>
+        <p:spPr>
+          <a:xfrm>
+            <a:off x="6858000" y="4069080"/>
+            <a:ext cx="1645920" cy="201168"/>
+          </a:xfrm>
+          <a:prstGeom prst="rect">
+            <a:avLst/>
+          </a:prstGeom>
+          <a:solidFill>
+            <a:srgbClr val="1A1A2E"/>
+          </a:solidFill>
+          <a:ln w="12700">
+            <a:solidFill>
+              <a:srgbClr val="2A2A3E"/>
+            </a:solidFill>
+          </a:ln>
+        </p:spPr>
+        <p:style>
+          <a:lnRef idx="1">
+            <a:schemeClr val="accent1"/>
+          </a:lnRef>
+          <a:fillRef idx="3">
+            <a:schemeClr val="accent1"/>
+          </a:fillRef>
+          <a:effectRef idx="2">
+            <a:schemeClr val="accent1"/>
+          </a:effectRef>
+          <a:fontRef idx="minor">
+            <a:schemeClr val="lt1"/>
+          </a:fontRef>
+        </p:style>
+        <p:txBody>
+          <a:bodyPr rtlCol="0" anchor="ctr"/>
+          <a:lstStyle/>
+          <a:p>
+            <a:pPr algn="ctr">
+              <a:defRPr sz="700" b="0">
+                <a:solidFill>
+                  <a:srgbClr val="CCCCCC"/>
+                </a:solidFill>
+                <a:latin typeface="Calibri"/>
+              </a:defRPr>
+            </a:pPr>
+            <a:r>
+              <a:t>Scale</a:t>
+            </a:r>
+          </a:p>
+        </p:txBody>
+      </p:sp>
+      <p:sp>
+        <p:nvSpPr>
+          <p:cNvPr id="77" name="Rectangle 76"/>
+          <p:cNvSpPr/>
+          <p:nvPr/>
+        </p:nvSpPr>
+        <p:spPr>
+          <a:xfrm>
+            <a:off x="8503920" y="4069080"/>
+            <a:ext cx="1097280" cy="201168"/>
+          </a:xfrm>
+          <a:prstGeom prst="rect">
+            <a:avLst/>
+          </a:prstGeom>
+          <a:solidFill>
+            <a:srgbClr val="1A1A2E"/>
+          </a:solidFill>
+          <a:ln w="12700">
+            <a:solidFill>
+              <a:srgbClr val="2A2A3E"/>
+            </a:solidFill>
+          </a:ln>
+        </p:spPr>
+        <p:style>
+          <a:lnRef idx="1">
+            <a:schemeClr val="accent1"/>
+          </a:lnRef>
+          <a:fillRef idx="3">
+            <a:schemeClr val="accent1"/>
+          </a:fillRef>
+          <a:effectRef idx="2">
+            <a:schemeClr val="accent1"/>
+          </a:effectRef>
+          <a:fontRef idx="minor">
+            <a:schemeClr val="lt1"/>
+          </a:fontRef>
+        </p:style>
+        <p:txBody>
+          <a:bodyPr rtlCol="0" anchor="ctr"/>
+          <a:lstStyle/>
+          <a:p>
+            <a:pPr algn="ctr">
+              <a:defRPr sz="700" b="0">
+                <a:solidFill>
+                  <a:srgbClr val="CCCCCC"/>
+                </a:solidFill>
+                <a:latin typeface="Calibri"/>
+              </a:defRPr>
+            </a:pPr>
+            <a:r>
+              <a:t>10,000</a:t>
+            </a:r>
+          </a:p>
+        </p:txBody>
+      </p:sp>
+      <p:sp>
+        <p:nvSpPr>
+          <p:cNvPr id="78" name="Rectangle 77"/>
+          <p:cNvSpPr/>
+          <p:nvPr/>
+        </p:nvSpPr>
+        <p:spPr>
+          <a:xfrm>
+            <a:off x="9601200" y="4069080"/>
+            <a:ext cx="1371600" cy="201168"/>
+          </a:xfrm>
+          <a:prstGeom prst="rect">
+            <a:avLst/>
+          </a:prstGeom>
+          <a:solidFill>
+            <a:srgbClr val="1A1A2E"/>
+          </a:solidFill>
+          <a:ln w="12700">
+            <a:solidFill>
+              <a:srgbClr val="2A2A3E"/>
+            </a:solidFill>
+          </a:ln>
+        </p:spPr>
+        <p:style>
+          <a:lnRef idx="1">
+            <a:schemeClr val="accent1"/>
+          </a:lnRef>
+          <a:fillRef idx="3">
+            <a:schemeClr val="accent1"/>
+          </a:fillRef>
+          <a:effectRef idx="2">
+            <a:schemeClr val="accent1"/>
+          </a:effectRef>
+          <a:fontRef idx="minor">
+            <a:schemeClr val="lt1"/>
+          </a:fontRef>
+        </p:style>
+        <p:txBody>
+          <a:bodyPr rtlCol="0" anchor="ctr"/>
+          <a:lstStyle/>
+          <a:p>
+            <a:pPr algn="ctr">
+              <a:defRPr sz="700" b="1">
+                <a:solidFill>
+                  <a:srgbClr val="34D399"/>
+                </a:solidFill>
+                <a:latin typeface="Calibri"/>
+              </a:defRPr>
+            </a:pPr>
+            <a:r>
+              <a:t>Rs.24.9L</a:t>
+            </a:r>
+          </a:p>
+        </p:txBody>
+      </p:sp>
+      <p:sp>
+        <p:nvSpPr>
+          <p:cNvPr id="79" name="Rectangle 78"/>
+          <p:cNvSpPr/>
+          <p:nvPr/>
+        </p:nvSpPr>
+        <p:spPr>
+          <a:xfrm>
+            <a:off x="6858000" y="4270248"/>
+            <a:ext cx="1645920" cy="201168"/>
+          </a:xfrm>
+          <a:prstGeom prst="rect">
+            <a:avLst/>
+          </a:prstGeom>
+          <a:solidFill>
+            <a:srgbClr val="151528"/>
+          </a:solidFill>
+          <a:ln w="12700">
+            <a:solidFill>
+              <a:srgbClr val="2A2A3E"/>
+            </a:solidFill>
+          </a:ln>
+        </p:spPr>
+        <p:style>
+          <a:lnRef idx="1">
+            <a:schemeClr val="accent1"/>
+          </a:lnRef>
+          <a:fillRef idx="3">
+            <a:schemeClr val="accent1"/>
+          </a:fillRef>
+          <a:effectRef idx="2">
+            <a:schemeClr val="accent1"/>
+          </a:effectRef>
+          <a:fontRef idx="minor">
+            <a:schemeClr val="lt1"/>
+          </a:fontRef>
+        </p:style>
+        <p:txBody>
+          <a:bodyPr rtlCol="0" anchor="ctr"/>
+          <a:lstStyle/>
+          <a:p>
+            <a:pPr algn="ctr">
+              <a:defRPr sz="700" b="0">
+                <a:solidFill>
+                  <a:srgbClr val="CCCCCC"/>
+                </a:solidFill>
+                <a:latin typeface="Calibri"/>
+              </a:defRPr>
+            </a:pPr>
+            <a:r>
+              <a:t>Expansion</a:t>
+            </a:r>
+          </a:p>
+        </p:txBody>
+      </p:sp>
+      <p:sp>
+        <p:nvSpPr>
+          <p:cNvPr id="80" name="Rectangle 79"/>
+          <p:cNvSpPr/>
+          <p:nvPr/>
+        </p:nvSpPr>
+        <p:spPr>
+          <a:xfrm>
+            <a:off x="8503920" y="4270248"/>
+            <a:ext cx="1097280" cy="201168"/>
+          </a:xfrm>
+          <a:prstGeom prst="rect">
+            <a:avLst/>
+          </a:prstGeom>
+          <a:solidFill>
+            <a:srgbClr val="151528"/>
+          </a:solidFill>
+          <a:ln w="12700">
+            <a:solidFill>
+              <a:srgbClr val="2A2A3E"/>
+            </a:solidFill>
+          </a:ln>
+        </p:spPr>
+        <p:style>
+          <a:lnRef idx="1">
+            <a:schemeClr val="accent1"/>
+          </a:lnRef>
+          <a:fillRef idx="3">
+            <a:schemeClr val="accent1"/>
+          </a:fillRef>
+          <a:effectRef idx="2">
+            <a:schemeClr val="accent1"/>
+          </a:effectRef>
+          <a:fontRef idx="minor">
+            <a:schemeClr val="lt1"/>
+          </a:fontRef>
+        </p:style>
+        <p:txBody>
+          <a:bodyPr rtlCol="0" anchor="ctr"/>
+          <a:lstStyle/>
+          <a:p>
+            <a:pPr algn="ctr">
+              <a:defRPr sz="700" b="0">
+                <a:solidFill>
+                  <a:srgbClr val="CCCCCC"/>
+                </a:solidFill>
+                <a:latin typeface="Calibri"/>
+              </a:defRPr>
+            </a:pPr>
+            <a:r>
+              <a:t>16,000</a:t>
+            </a:r>
+          </a:p>
+        </p:txBody>
+      </p:sp>
+      <p:sp>
+        <p:nvSpPr>
+          <p:cNvPr id="81" name="Rectangle 80"/>
+          <p:cNvSpPr/>
+          <p:nvPr/>
+        </p:nvSpPr>
+        <p:spPr>
+          <a:xfrm>
+            <a:off x="9601200" y="4270248"/>
+            <a:ext cx="1371600" cy="201168"/>
+          </a:xfrm>
+          <a:prstGeom prst="rect">
+            <a:avLst/>
+          </a:prstGeom>
+          <a:solidFill>
+            <a:srgbClr val="151528"/>
+          </a:solidFill>
+          <a:ln w="12700">
+            <a:solidFill>
+              <a:srgbClr val="2A2A3E"/>
+            </a:solidFill>
+          </a:ln>
+        </p:spPr>
+        <p:style>
+          <a:lnRef idx="1">
+            <a:schemeClr val="accent1"/>
+          </a:lnRef>
+          <a:fillRef idx="3">
+            <a:schemeClr val="accent1"/>
+          </a:fillRef>
+          <a:effectRef idx="2">
+            <a:schemeClr val="accent1"/>
+          </a:effectRef>
+          <a:fontRef idx="minor">
+            <a:schemeClr val="lt1"/>
+          </a:fontRef>
+        </p:style>
+        <p:txBody>
+          <a:bodyPr rtlCol="0" anchor="ctr"/>
+          <a:lstStyle/>
+          <a:p>
+            <a:pPr algn="ctr">
+              <a:defRPr sz="700" b="1">
+                <a:solidFill>
+                  <a:srgbClr val="34D399"/>
+                </a:solidFill>
+                <a:latin typeface="Calibri"/>
+              </a:defRPr>
+            </a:pPr>
+            <a:r>
+              <a:t>Rs.47.8L</a:t>
+            </a:r>
+          </a:p>
+        </p:txBody>
+      </p:sp>
+      <p:sp>
+        <p:nvSpPr>
+          <p:cNvPr id="82" name="TextBox 81"/>
+          <p:cNvSpPr txBox="1"/>
+          <p:nvPr/>
+        </p:nvSpPr>
+        <p:spPr>
+          <a:xfrm>
+            <a:off x="6858000" y="4572000"/>
+            <a:ext cx="5029200" cy="228600"/>
+          </a:xfrm>
+          <a:prstGeom prst="rect">
+            <a:avLst/>
+          </a:prstGeom>
+          <a:noFill/>
+        </p:spPr>
+        <p:txBody>
+          <a:bodyPr wrap="square">
+            <a:spAutoFit/>
+          </a:bodyPr>
+          <a:lstStyle/>
+          <a:p>
+            <a:pPr algn="l">
+              <a:defRPr sz="1100" b="1">
+                <a:solidFill>
+                  <a:srgbClr val="A78BFA"/>
+                </a:solidFill>
+                <a:latin typeface="Calibri"/>
+              </a:defRPr>
+            </a:pPr>
+            <a:r>
+              <a:t>Investor Summary</a:t>
+            </a:r>
+          </a:p>
+        </p:txBody>
+      </p:sp>
+      <p:sp>
+        <p:nvSpPr>
+          <p:cNvPr id="83" name="Rectangle 82"/>
+          <p:cNvSpPr/>
+          <p:nvPr/>
+        </p:nvSpPr>
+        <p:spPr>
+          <a:xfrm>
+            <a:off x="6858000" y="4800600"/>
+            <a:ext cx="914400" cy="201168"/>
+          </a:xfrm>
+          <a:prstGeom prst="rect">
+            <a:avLst/>
+          </a:prstGeom>
+          <a:solidFill>
+            <a:srgbClr val="A78BFA"/>
+          </a:solidFill>
+          <a:ln>
+            <a:noFill/>
+          </a:ln>
+        </p:spPr>
+        <p:style>
+          <a:lnRef idx="1">
+            <a:schemeClr val="accent1"/>
+          </a:lnRef>
+          <a:fillRef idx="3">
+            <a:schemeClr val="accent1"/>
+          </a:fillRef>
+          <a:effectRef idx="2">
+            <a:schemeClr val="accent1"/>
+          </a:effectRef>
+          <a:fontRef idx="minor">
+            <a:schemeClr val="lt1"/>
+          </a:fontRef>
+        </p:style>
+        <p:txBody>
+          <a:bodyPr rtlCol="0" anchor="ctr"/>
+          <a:lstStyle/>
+          <a:p>
+            <a:pPr algn="ctr">
+              <a:defRPr sz="700" b="1">
+                <a:solidFill>
+                  <a:srgbClr val="FFFFFF"/>
+                </a:solidFill>
+                <a:latin typeface="Calibri"/>
+              </a:defRPr>
+            </a:pPr>
+            <a:r>
+              <a:t>Year</a:t>
+            </a:r>
+          </a:p>
+        </p:txBody>
+      </p:sp>
+      <p:sp>
+        <p:nvSpPr>
+          <p:cNvPr id="84" name="Rectangle 83"/>
+          <p:cNvSpPr/>
+          <p:nvPr/>
+        </p:nvSpPr>
+        <p:spPr>
+          <a:xfrm>
+            <a:off x="7772400" y="4800600"/>
+            <a:ext cx="1188720" cy="201168"/>
+          </a:xfrm>
+          <a:prstGeom prst="rect">
+            <a:avLst/>
+          </a:prstGeom>
+          <a:solidFill>
+            <a:srgbClr val="A78BFA"/>
+          </a:solidFill>
+          <a:ln>
+            <a:noFill/>
+          </a:ln>
+        </p:spPr>
+        <p:style>
+          <a:lnRef idx="1">
+            <a:schemeClr val="accent1"/>
+          </a:lnRef>
+          <a:fillRef idx="3">
+            <a:schemeClr val="accent1"/>
+          </a:fillRef>
+          <a:effectRef idx="2">
+            <a:schemeClr val="accent1"/>
+          </a:effectRef>
+          <a:fontRef idx="minor">
+            <a:schemeClr val="lt1"/>
+          </a:fontRef>
+        </p:style>
+        <p:txBody>
+          <a:bodyPr rtlCol="0" anchor="ctr"/>
+          <a:lstStyle/>
+          <a:p>
+            <a:pPr algn="ctr">
+              <a:defRPr sz="700" b="1">
+                <a:solidFill>
+                  <a:srgbClr val="FFFFFF"/>
+                </a:solidFill>
+                <a:latin typeface="Calibri"/>
+              </a:defRPr>
+            </a:pPr>
+            <a:r>
+              <a:t>Revenue</a:t>
+            </a:r>
+          </a:p>
+        </p:txBody>
+      </p:sp>
+      <p:sp>
+        <p:nvSpPr>
+          <p:cNvPr id="85" name="Rectangle 84"/>
+          <p:cNvSpPr/>
+          <p:nvPr/>
+        </p:nvSpPr>
+        <p:spPr>
+          <a:xfrm>
+            <a:off x="8961120" y="4800600"/>
+            <a:ext cx="1097280" cy="201168"/>
+          </a:xfrm>
+          <a:prstGeom prst="rect">
+            <a:avLst/>
+          </a:prstGeom>
+          <a:solidFill>
+            <a:srgbClr val="A78BFA"/>
+          </a:solidFill>
+          <a:ln>
+            <a:noFill/>
+          </a:ln>
+        </p:spPr>
+        <p:style>
+          <a:lnRef idx="1">
+            <a:schemeClr val="accent1"/>
+          </a:lnRef>
+          <a:fillRef idx="3">
+            <a:schemeClr val="accent1"/>
+          </a:fillRef>
+          <a:effectRef idx="2">
+            <a:schemeClr val="accent1"/>
+          </a:effectRef>
+          <a:fontRef idx="minor">
+            <a:schemeClr val="lt1"/>
+          </a:fontRef>
+        </p:style>
+        <p:txBody>
+          <a:bodyPr rtlCol="0" anchor="ctr"/>
+          <a:lstStyle/>
+          <a:p>
+            <a:pPr algn="ctr">
+              <a:defRPr sz="700" b="1">
+                <a:solidFill>
+                  <a:srgbClr val="FFFFFF"/>
+                </a:solidFill>
+                <a:latin typeface="Calibri"/>
+              </a:defRPr>
+            </a:pPr>
+            <a:r>
+              <a:t>Expenses</a:t>
+            </a:r>
+          </a:p>
+        </p:txBody>
+      </p:sp>
+      <p:sp>
+        <p:nvSpPr>
+          <p:cNvPr id="86" name="Rectangle 85"/>
+          <p:cNvSpPr/>
+          <p:nvPr/>
+        </p:nvSpPr>
+        <p:spPr>
+          <a:xfrm>
+            <a:off x="10058400" y="4800600"/>
+            <a:ext cx="914400" cy="201168"/>
+          </a:xfrm>
+          <a:prstGeom prst="rect">
+            <a:avLst/>
+          </a:prstGeom>
+          <a:solidFill>
+            <a:srgbClr val="A78BFA"/>
+          </a:solidFill>
+          <a:ln>
+            <a:noFill/>
+          </a:ln>
+        </p:spPr>
+        <p:style>
+          <a:lnRef idx="1">
+            <a:schemeClr val="accent1"/>
+          </a:lnRef>
+          <a:fillRef idx="3">
+            <a:schemeClr val="accent1"/>
+          </a:fillRef>
+          <a:effectRef idx="2">
+            <a:schemeClr val="accent1"/>
+          </a:effectRef>
+          <a:fontRef idx="minor">
+            <a:schemeClr val="lt1"/>
+          </a:fontRef>
+        </p:style>
+        <p:txBody>
+          <a:bodyPr rtlCol="0" anchor="ctr"/>
+          <a:lstStyle/>
+          <a:p>
+            <a:pPr algn="ctr">
+              <a:defRPr sz="700" b="1">
+                <a:solidFill>
+                  <a:srgbClr val="FFFFFF"/>
+                </a:solidFill>
+                <a:latin typeface="Calibri"/>
+              </a:defRPr>
+            </a:pPr>
+            <a:r>
+              <a:t>EBITDA</a:t>
+            </a:r>
+          </a:p>
+        </p:txBody>
+      </p:sp>
+      <p:sp>
+        <p:nvSpPr>
+          <p:cNvPr id="87" name="Rectangle 86"/>
+          <p:cNvSpPr/>
+          <p:nvPr/>
+        </p:nvSpPr>
+        <p:spPr>
+          <a:xfrm>
+            <a:off x="6858000" y="5001768"/>
+            <a:ext cx="914400" cy="201168"/>
+          </a:xfrm>
+          <a:prstGeom prst="rect">
+            <a:avLst/>
+          </a:prstGeom>
+          <a:solidFill>
+            <a:srgbClr val="1A1A2E"/>
+          </a:solidFill>
+          <a:ln w="12700">
+            <a:solidFill>
+              <a:srgbClr val="2A2A3E"/>
+            </a:solidFill>
+          </a:ln>
+        </p:spPr>
+        <p:style>
+          <a:lnRef idx="1">
+            <a:schemeClr val="accent1"/>
+          </a:lnRef>
+          <a:fillRef idx="3">
+            <a:schemeClr val="accent1"/>
+          </a:fillRef>
+          <a:effectRef idx="2">
+            <a:schemeClr val="accent1"/>
+          </a:effectRef>
+          <a:fontRef idx="minor">
+            <a:schemeClr val="lt1"/>
+          </a:fontRef>
+        </p:style>
+        <p:txBody>
+          <a:bodyPr rtlCol="0" anchor="ctr"/>
+          <a:lstStyle/>
+          <a:p>
+            <a:pPr algn="ctr">
+              <a:defRPr sz="700" b="0">
+                <a:solidFill>
+                  <a:srgbClr val="CCCCCC"/>
+                </a:solidFill>
+                <a:latin typeface="Calibri"/>
+              </a:defRPr>
+            </a:pPr>
+            <a:r>
+              <a:t>Y1</a:t>
+            </a:r>
+          </a:p>
+        </p:txBody>
+      </p:sp>
+      <p:sp>
+        <p:nvSpPr>
+          <p:cNvPr id="88" name="Rectangle 87"/>
+          <p:cNvSpPr/>
+          <p:nvPr/>
+        </p:nvSpPr>
+        <p:spPr>
+          <a:xfrm>
+            <a:off x="7772400" y="5001768"/>
+            <a:ext cx="1188720" cy="201168"/>
+          </a:xfrm>
+          <a:prstGeom prst="rect">
+            <a:avLst/>
+          </a:prstGeom>
+          <a:solidFill>
+            <a:srgbClr val="1A1A2E"/>
+          </a:solidFill>
+          <a:ln w="12700">
+            <a:solidFill>
+              <a:srgbClr val="2A2A3E"/>
+            </a:solidFill>
+          </a:ln>
+        </p:spPr>
+        <p:style>
+          <a:lnRef idx="1">
+            <a:schemeClr val="accent1"/>
+          </a:lnRef>
+          <a:fillRef idx="3">
+            <a:schemeClr val="accent1"/>
+          </a:fillRef>
+          <a:effectRef idx="2">
+            <a:schemeClr val="accent1"/>
+          </a:effectRef>
+          <a:fontRef idx="minor">
+            <a:schemeClr val="lt1"/>
+          </a:fontRef>
+        </p:style>
+        <p:txBody>
+          <a:bodyPr rtlCol="0" anchor="ctr"/>
+          <a:lstStyle/>
+          <a:p>
+            <a:pPr algn="ctr">
+              <a:defRPr sz="700" b="0">
+                <a:solidFill>
+                  <a:srgbClr val="CCCCCC"/>
+                </a:solidFill>
+                <a:latin typeface="Calibri"/>
+              </a:defRPr>
+            </a:pPr>
+            <a:r>
+              <a:t>Rs.12.9L</a:t>
+            </a:r>
+          </a:p>
+        </p:txBody>
+      </p:sp>
+      <p:sp>
+        <p:nvSpPr>
+          <p:cNvPr id="89" name="Rectangle 88"/>
+          <p:cNvSpPr/>
+          <p:nvPr/>
+        </p:nvSpPr>
+        <p:spPr>
+          <a:xfrm>
+            <a:off x="8961120" y="5001768"/>
+            <a:ext cx="1097280" cy="201168"/>
+          </a:xfrm>
+          <a:prstGeom prst="rect">
+            <a:avLst/>
+          </a:prstGeom>
+          <a:solidFill>
+            <a:srgbClr val="1A1A2E"/>
+          </a:solidFill>
+          <a:ln w="12700">
+            <a:solidFill>
+              <a:srgbClr val="2A2A3E"/>
+            </a:solidFill>
+          </a:ln>
+        </p:spPr>
+        <p:style>
+          <a:lnRef idx="1">
+            <a:schemeClr val="accent1"/>
+          </a:lnRef>
+          <a:fillRef idx="3">
+            <a:schemeClr val="accent1"/>
+          </a:fillRef>
+          <a:effectRef idx="2">
+            <a:schemeClr val="accent1"/>
+          </a:effectRef>
+          <a:fontRef idx="minor">
+            <a:schemeClr val="lt1"/>
+          </a:fontRef>
+        </p:style>
+        <p:txBody>
+          <a:bodyPr rtlCol="0" anchor="ctr"/>
+          <a:lstStyle/>
+          <a:p>
+            <a:pPr algn="ctr">
+              <a:defRPr sz="700" b="0">
+                <a:solidFill>
+                  <a:srgbClr val="CCCCCC"/>
+                </a:solidFill>
+                <a:latin typeface="Calibri"/>
+              </a:defRPr>
+            </a:pPr>
+            <a:r>
+              <a:t>Rs.6L</a:t>
+            </a:r>
+          </a:p>
+        </p:txBody>
+      </p:sp>
+      <p:sp>
+        <p:nvSpPr>
+          <p:cNvPr id="90" name="Rectangle 89"/>
+          <p:cNvSpPr/>
+          <p:nvPr/>
+        </p:nvSpPr>
+        <p:spPr>
+          <a:xfrm>
+            <a:off x="10058400" y="5001768"/>
+            <a:ext cx="914400" cy="201168"/>
+          </a:xfrm>
+          <a:prstGeom prst="rect">
+            <a:avLst/>
+          </a:prstGeom>
+          <a:solidFill>
+            <a:srgbClr val="1A1A2E"/>
+          </a:solidFill>
+          <a:ln w="12700">
+            <a:solidFill>
+              <a:srgbClr val="2A2A3E"/>
+            </a:solidFill>
+          </a:ln>
+        </p:spPr>
+        <p:style>
+          <a:lnRef idx="1">
+            <a:schemeClr val="accent1"/>
+          </a:lnRef>
+          <a:fillRef idx="3">
+            <a:schemeClr val="accent1"/>
+          </a:fillRef>
+          <a:effectRef idx="2">
+            <a:schemeClr val="accent1"/>
+          </a:effectRef>
+          <a:fontRef idx="minor">
+            <a:schemeClr val="lt1"/>
+          </a:fontRef>
+        </p:style>
+        <p:txBody>
+          <a:bodyPr rtlCol="0" anchor="ctr"/>
+          <a:lstStyle/>
+          <a:p>
+            <a:pPr algn="ctr">
+              <a:defRPr sz="700" b="1">
+                <a:solidFill>
+                  <a:srgbClr val="34D399"/>
+                </a:solidFill>
+                <a:latin typeface="Calibri"/>
+              </a:defRPr>
+            </a:pPr>
+            <a:r>
+              <a:t>Rs.6.9L</a:t>
+            </a:r>
+          </a:p>
+        </p:txBody>
+      </p:sp>
+      <p:sp>
+        <p:nvSpPr>
+          <p:cNvPr id="91" name="Rectangle 90"/>
+          <p:cNvSpPr/>
+          <p:nvPr/>
+        </p:nvSpPr>
+        <p:spPr>
+          <a:xfrm>
+            <a:off x="6858000" y="5202936"/>
+            <a:ext cx="914400" cy="201168"/>
+          </a:xfrm>
+          <a:prstGeom prst="rect">
+            <a:avLst/>
+          </a:prstGeom>
+          <a:solidFill>
+            <a:srgbClr val="151528"/>
+          </a:solidFill>
+          <a:ln w="12700">
+            <a:solidFill>
+              <a:srgbClr val="2A2A3E"/>
+            </a:solidFill>
+          </a:ln>
+        </p:spPr>
+        <p:style>
+          <a:lnRef idx="1">
+            <a:schemeClr val="accent1"/>
+          </a:lnRef>
+          <a:fillRef idx="3">
+            <a:schemeClr val="accent1"/>
+          </a:fillRef>
+          <a:effectRef idx="2">
+            <a:schemeClr val="accent1"/>
+          </a:effectRef>
+          <a:fontRef idx="minor">
+            <a:schemeClr val="lt1"/>
+          </a:fontRef>
+        </p:style>
+        <p:txBody>
+          <a:bodyPr rtlCol="0" anchor="ctr"/>
+          <a:lstStyle/>
+          <a:p>
+            <a:pPr algn="ctr">
+              <a:defRPr sz="700" b="0">
+                <a:solidFill>
+                  <a:srgbClr val="CCCCCC"/>
+                </a:solidFill>
+                <a:latin typeface="Calibri"/>
+              </a:defRPr>
+            </a:pPr>
+            <a:r>
+              <a:t>Y2</a:t>
+            </a:r>
+          </a:p>
+        </p:txBody>
+      </p:sp>
+      <p:sp>
+        <p:nvSpPr>
+          <p:cNvPr id="92" name="Rectangle 91"/>
+          <p:cNvSpPr/>
+          <p:nvPr/>
+        </p:nvSpPr>
+        <p:spPr>
+          <a:xfrm>
+            <a:off x="7772400" y="5202936"/>
+            <a:ext cx="1188720" cy="201168"/>
+          </a:xfrm>
+          <a:prstGeom prst="rect">
+            <a:avLst/>
+          </a:prstGeom>
+          <a:solidFill>
+            <a:srgbClr val="151528"/>
+          </a:solidFill>
+          <a:ln w="12700">
+            <a:solidFill>
+              <a:srgbClr val="2A2A3E"/>
+            </a:solidFill>
+          </a:ln>
+        </p:spPr>
+        <p:style>
+          <a:lnRef idx="1">
+            <a:schemeClr val="accent1"/>
+          </a:lnRef>
+          <a:fillRef idx="3">
+            <a:schemeClr val="accent1"/>
+          </a:fillRef>
+          <a:effectRef idx="2">
+            <a:schemeClr val="accent1"/>
+          </a:effectRef>
+          <a:fontRef idx="minor">
+            <a:schemeClr val="lt1"/>
+          </a:fontRef>
+        </p:style>
+        <p:txBody>
+          <a:bodyPr rtlCol="0" anchor="ctr"/>
+          <a:lstStyle/>
+          <a:p>
+            <a:pPr algn="ctr">
+              <a:defRPr sz="700" b="0">
+                <a:solidFill>
+                  <a:srgbClr val="CCCCCC"/>
+                </a:solidFill>
+                <a:latin typeface="Calibri"/>
+              </a:defRPr>
+            </a:pPr>
+            <a:r>
+              <a:t>Rs.1.02Cr</a:t>
+            </a:r>
+          </a:p>
+        </p:txBody>
+      </p:sp>
+      <p:sp>
+        <p:nvSpPr>
+          <p:cNvPr id="93" name="Rectangle 92"/>
+          <p:cNvSpPr/>
+          <p:nvPr/>
+        </p:nvSpPr>
+        <p:spPr>
+          <a:xfrm>
+            <a:off x="8961120" y="5202936"/>
+            <a:ext cx="1097280" cy="201168"/>
+          </a:xfrm>
+          <a:prstGeom prst="rect">
+            <a:avLst/>
+          </a:prstGeom>
+          <a:solidFill>
+            <a:srgbClr val="151528"/>
+          </a:solidFill>
+          <a:ln w="12700">
+            <a:solidFill>
+              <a:srgbClr val="2A2A3E"/>
+            </a:solidFill>
+          </a:ln>
+        </p:spPr>
+        <p:style>
+          <a:lnRef idx="1">
+            <a:schemeClr val="accent1"/>
+          </a:lnRef>
+          <a:fillRef idx="3">
+            <a:schemeClr val="accent1"/>
+          </a:fillRef>
+          <a:effectRef idx="2">
+            <a:schemeClr val="accent1"/>
+          </a:effectRef>
+          <a:fontRef idx="minor">
+            <a:schemeClr val="lt1"/>
+          </a:fontRef>
+        </p:style>
+        <p:txBody>
+          <a:bodyPr rtlCol="0" anchor="ctr"/>
+          <a:lstStyle/>
+          <a:p>
+            <a:pPr algn="ctr">
+              <a:defRPr sz="700" b="0">
+                <a:solidFill>
+                  <a:srgbClr val="CCCCCC"/>
+                </a:solidFill>
+                <a:latin typeface="Calibri"/>
+              </a:defRPr>
+            </a:pPr>
+            <a:r>
+              <a:t>Rs.35L</a:t>
+            </a:r>
+          </a:p>
+        </p:txBody>
+      </p:sp>
+      <p:sp>
+        <p:nvSpPr>
+          <p:cNvPr id="94" name="Rectangle 93"/>
+          <p:cNvSpPr/>
+          <p:nvPr/>
+        </p:nvSpPr>
+        <p:spPr>
+          <a:xfrm>
+            <a:off x="10058400" y="5202936"/>
+            <a:ext cx="914400" cy="201168"/>
+          </a:xfrm>
+          <a:prstGeom prst="rect">
+            <a:avLst/>
+          </a:prstGeom>
+          <a:solidFill>
+            <a:srgbClr val="151528"/>
+          </a:solidFill>
+          <a:ln w="12700">
+            <a:solidFill>
+              <a:srgbClr val="2A2A3E"/>
+            </a:solidFill>
+          </a:ln>
+        </p:spPr>
+        <p:style>
+          <a:lnRef idx="1">
+            <a:schemeClr val="accent1"/>
+          </a:lnRef>
+          <a:fillRef idx="3">
+            <a:schemeClr val="accent1"/>
+          </a:fillRef>
+          <a:effectRef idx="2">
+            <a:schemeClr val="accent1"/>
+          </a:effectRef>
+          <a:fontRef idx="minor">
+            <a:schemeClr val="lt1"/>
+          </a:fontRef>
+        </p:style>
+        <p:txBody>
+          <a:bodyPr rtlCol="0" anchor="ctr"/>
+          <a:lstStyle/>
+          <a:p>
+            <a:pPr algn="ctr">
+              <a:defRPr sz="700" b="1">
+                <a:solidFill>
+                  <a:srgbClr val="34D399"/>
+                </a:solidFill>
+                <a:latin typeface="Calibri"/>
+              </a:defRPr>
+            </a:pPr>
+            <a:r>
+              <a:t>Rs.67L</a:t>
+            </a:r>
+          </a:p>
+        </p:txBody>
+      </p:sp>
+      <p:sp>
+        <p:nvSpPr>
+          <p:cNvPr id="95" name="Rectangle 94"/>
+          <p:cNvSpPr/>
+          <p:nvPr/>
+        </p:nvSpPr>
+        <p:spPr>
+          <a:xfrm>
+            <a:off x="6858000" y="5404104"/>
+            <a:ext cx="914400" cy="201168"/>
+          </a:xfrm>
+          <a:prstGeom prst="rect">
+            <a:avLst/>
+          </a:prstGeom>
+          <a:solidFill>
+            <a:srgbClr val="1A1A2E"/>
+          </a:solidFill>
+          <a:ln w="12700">
+            <a:solidFill>
+              <a:srgbClr val="2A2A3E"/>
+            </a:solidFill>
+          </a:ln>
+        </p:spPr>
+        <p:style>
+          <a:lnRef idx="1">
+            <a:schemeClr val="accent1"/>
+          </a:lnRef>
+          <a:fillRef idx="3">
+            <a:schemeClr val="accent1"/>
+          </a:fillRef>
+          <a:effectRef idx="2">
+            <a:schemeClr val="accent1"/>
+          </a:effectRef>
+          <a:fontRef idx="minor">
+            <a:schemeClr val="lt1"/>
+          </a:fontRef>
+        </p:style>
+        <p:txBody>
+          <a:bodyPr rtlCol="0" anchor="ctr"/>
+          <a:lstStyle/>
+          <a:p>
+            <a:pPr algn="ctr">
+              <a:defRPr sz="700" b="0">
+                <a:solidFill>
+                  <a:srgbClr val="CCCCCC"/>
+                </a:solidFill>
+                <a:latin typeface="Calibri"/>
+              </a:defRPr>
+            </a:pPr>
+            <a:r>
+              <a:t>Y3</a:t>
+            </a:r>
+          </a:p>
+        </p:txBody>
+      </p:sp>
+      <p:sp>
+        <p:nvSpPr>
+          <p:cNvPr id="96" name="Rectangle 95"/>
+          <p:cNvSpPr/>
+          <p:nvPr/>
+        </p:nvSpPr>
+        <p:spPr>
+          <a:xfrm>
+            <a:off x="7772400" y="5404104"/>
+            <a:ext cx="1188720" cy="201168"/>
+          </a:xfrm>
+          <a:prstGeom prst="rect">
+            <a:avLst/>
+          </a:prstGeom>
+          <a:solidFill>
+            <a:srgbClr val="1A1A2E"/>
+          </a:solidFill>
+          <a:ln w="12700">
+            <a:solidFill>
+              <a:srgbClr val="2A2A3E"/>
+            </a:solidFill>
+          </a:ln>
+        </p:spPr>
+        <p:style>
+          <a:lnRef idx="1">
+            <a:schemeClr val="accent1"/>
+          </a:lnRef>
+          <a:fillRef idx="3">
+            <a:schemeClr val="accent1"/>
+          </a:fillRef>
+          <a:effectRef idx="2">
+            <a:schemeClr val="accent1"/>
+          </a:effectRef>
+          <a:fontRef idx="minor">
+            <a:schemeClr val="lt1"/>
+          </a:fontRef>
+        </p:style>
+        <p:txBody>
+          <a:bodyPr rtlCol="0" anchor="ctr"/>
+          <a:lstStyle/>
+          <a:p>
+            <a:pPr algn="ctr">
+              <a:defRPr sz="700" b="0">
+                <a:solidFill>
+                  <a:srgbClr val="CCCCCC"/>
+                </a:solidFill>
+                <a:latin typeface="Calibri"/>
+              </a:defRPr>
+            </a:pPr>
+            <a:r>
+              <a:t>Rs.7.14Cr</a:t>
+            </a:r>
+          </a:p>
+        </p:txBody>
+      </p:sp>
+      <p:sp>
+        <p:nvSpPr>
+          <p:cNvPr id="97" name="Rectangle 96"/>
+          <p:cNvSpPr/>
+          <p:nvPr/>
+        </p:nvSpPr>
+        <p:spPr>
+          <a:xfrm>
+            <a:off x="8961120" y="5404104"/>
+            <a:ext cx="1097280" cy="201168"/>
+          </a:xfrm>
+          <a:prstGeom prst="rect">
+            <a:avLst/>
+          </a:prstGeom>
+          <a:solidFill>
+            <a:srgbClr val="1A1A2E"/>
+          </a:solidFill>
+          <a:ln w="12700">
+            <a:solidFill>
+              <a:srgbClr val="2A2A3E"/>
+            </a:solidFill>
+          </a:ln>
+        </p:spPr>
+        <p:style>
+          <a:lnRef idx="1">
+            <a:schemeClr val="accent1"/>
+          </a:lnRef>
+          <a:fillRef idx="3">
+            <a:schemeClr val="accent1"/>
+          </a:fillRef>
+          <a:effectRef idx="2">
+            <a:schemeClr val="accent1"/>
+          </a:effectRef>
+          <a:fontRef idx="minor">
+            <a:schemeClr val="lt1"/>
+          </a:fontRef>
+        </p:style>
+        <p:txBody>
+          <a:bodyPr rtlCol="0" anchor="ctr"/>
+          <a:lstStyle/>
+          <a:p>
+            <a:pPr algn="ctr">
+              <a:defRPr sz="700" b="0">
+                <a:solidFill>
+                  <a:srgbClr val="CCCCCC"/>
+                </a:solidFill>
+                <a:latin typeface="Calibri"/>
+              </a:defRPr>
+            </a:pPr>
+            <a:r>
+              <a:t>Rs.1.9Cr</a:t>
+            </a:r>
+          </a:p>
+        </p:txBody>
+      </p:sp>
+      <p:sp>
+        <p:nvSpPr>
+          <p:cNvPr id="98" name="Rectangle 97"/>
+          <p:cNvSpPr/>
+          <p:nvPr/>
+        </p:nvSpPr>
+        <p:spPr>
+          <a:xfrm>
+            <a:off x="10058400" y="5404104"/>
+            <a:ext cx="914400" cy="201168"/>
+          </a:xfrm>
+          <a:prstGeom prst="rect">
+            <a:avLst/>
+          </a:prstGeom>
+          <a:solidFill>
+            <a:srgbClr val="1A1A2E"/>
+          </a:solidFill>
+          <a:ln w="12700">
+            <a:solidFill>
+              <a:srgbClr val="2A2A3E"/>
+            </a:solidFill>
+          </a:ln>
+        </p:spPr>
+        <p:style>
+          <a:lnRef idx="1">
+            <a:schemeClr val="accent1"/>
+          </a:lnRef>
+          <a:fillRef idx="3">
+            <a:schemeClr val="accent1"/>
+          </a:fillRef>
+          <a:effectRef idx="2">
+            <a:schemeClr val="accent1"/>
+          </a:effectRef>
+          <a:fontRef idx="minor">
+            <a:schemeClr val="lt1"/>
+          </a:fontRef>
+        </p:style>
+        <p:txBody>
+          <a:bodyPr rtlCol="0" anchor="ctr"/>
+          <a:lstStyle/>
+          <a:p>
+            <a:pPr algn="ctr">
+              <a:defRPr sz="700" b="1">
+                <a:solidFill>
+                  <a:srgbClr val="34D399"/>
+                </a:solidFill>
+                <a:latin typeface="Calibri"/>
+              </a:defRPr>
+            </a:pPr>
+            <a:r>
+              <a:t>Rs.5.24Cr</a:t>
+            </a:r>
+          </a:p>
+        </p:txBody>
+      </p:sp>
+      <p:sp>
+        <p:nvSpPr>
+          <p:cNvPr id="99" name="TextBox 98"/>
+          <p:cNvSpPr txBox="1"/>
+          <p:nvPr/>
+        </p:nvSpPr>
+        <p:spPr>
+          <a:xfrm>
+            <a:off x="731520" y="5120640"/>
+            <a:ext cx="10515600" cy="274320"/>
+          </a:xfrm>
+          <a:prstGeom prst="rect">
+            <a:avLst/>
+          </a:prstGeom>
+          <a:noFill/>
+        </p:spPr>
+        <p:txBody>
+          <a:bodyPr wrap="square">
+            <a:spAutoFit/>
+          </a:bodyPr>
+          <a:lstStyle/>
+          <a:p>
+            <a:pPr algn="ctr">
+              <a:defRPr sz="800" b="0">
+                <a:solidFill>
+                  <a:srgbClr val="888888"/>
+                </a:solidFill>
+                <a:latin typeface="Calibri"/>
+              </a:defRPr>
+            </a:pPr>
+            <a:r>
+              <a:t>Conservative scenario: 35K users Y2 (Rs.52L) / 100K Y3 (Rs.2.2Cr). Upside exceeds Rs.5Cr ARR if conversion and retention outperform.</a:t>
+            </a:r>
+          </a:p>
+        </p:txBody>
+      </p:sp>
+      <p:sp>
+        <p:nvSpPr>
+          <p:cNvPr id="100" name="TextBox 99"/>
           <p:cNvSpPr txBox="1"/>
           <p:nvPr/>
         </p:nvSpPr>

</xml_diff>